<commit_message>
fix: align agenda linkage deck evidence
</commit_message>
<xml_diff>
--- a/evaluation/presentation-linkage/20260704_process_to_conclusion_linkage.pptx
+++ b/evaluation/presentation-linkage/20260704_process_to_conclusion_linkage.pptx
@@ -14,6 +14,7 @@
     <p:sldId id="262" r:id="rId13"/>
     <p:sldId id="263" r:id="rId14"/>
     <p:sldId id="264" r:id="rId15"/>
+    <p:sldId id="265" r:id="rId16"/>
   </p:sldIdLst>
   <p:sldSz cx="12191695" cy="6858000" type="screen4x3"/>
   <p:notesSz cx="6858000" cy="9144000"/>
@@ -3493,6 +3494,292 @@
 </p:sld>
 </file>
 
+<file path=ppt/slides/slide10.xml><?xml version="1.0" encoding="utf-8"?>
+<p:sld xmlns:a="http://schemas.openxmlformats.org/drawingml/2006/main" xmlns:p="http://schemas.openxmlformats.org/presentationml/2006/main" xmlns:r="http://schemas.openxmlformats.org/officeDocument/2006/relationships">
+  <p:cSld>
+    <p:bg>
+      <p:bgPr>
+        <a:solidFill>
+          <a:srgbClr val="F8FAFC"/>
+        </a:solidFill>
+        <a:effectLst/>
+      </p:bgPr>
+    </p:bg>
+    <p:spTree>
+      <p:nvGrpSpPr>
+        <p:cNvPr id="1" name=""/>
+        <p:cNvGrpSpPr/>
+        <p:nvPr/>
+      </p:nvGrpSpPr>
+      <p:grpSpPr/>
+      <p:sp>
+        <p:nvSpPr>
+          <p:cNvPr id="2" name="TextBox 1"/>
+          <p:cNvSpPr txBox="1"/>
+          <p:nvPr/>
+        </p:nvSpPr>
+        <p:spPr>
+          <a:xfrm>
+            <a:off x="594360" y="320040"/>
+            <a:ext cx="10607040" cy="502920"/>
+          </a:xfrm>
+          <a:prstGeom prst="rect">
+            <a:avLst/>
+          </a:prstGeom>
+          <a:noFill/>
+        </p:spPr>
+        <p:txBody>
+          <a:bodyPr wrap="square" lIns="73152" rIns="73152" tIns="36576" bIns="36576" anchor="t">
+            <a:spAutoFit/>
+          </a:bodyPr>
+          <a:lstStyle/>
+          <a:p>
+            <a:pPr algn="l">
+              <a:defRPr sz="2400" b="1">
+                <a:solidFill>
+                  <a:srgbClr val="1F2937"/>
+                </a:solidFill>
+                <a:latin typeface="Malgun Gothic"/>
+              </a:defRPr>
+            </a:pPr>
+            <a:r>
+              <a:t>9. 발표용 한 문장</a:t>
+            </a:r>
+          </a:p>
+        </p:txBody>
+      </p:sp>
+      <p:sp>
+        <p:nvSpPr>
+          <p:cNvPr id="3" name="TextBox 2"/>
+          <p:cNvSpPr txBox="1"/>
+          <p:nvPr/>
+        </p:nvSpPr>
+        <p:spPr>
+          <a:xfrm>
+            <a:off x="603504" y="841248"/>
+            <a:ext cx="10698480" cy="292608"/>
+          </a:xfrm>
+          <a:prstGeom prst="rect">
+            <a:avLst/>
+          </a:prstGeom>
+          <a:noFill/>
+        </p:spPr>
+        <p:txBody>
+          <a:bodyPr wrap="square" lIns="73152" rIns="73152" tIns="36576" bIns="36576" anchor="t">
+            <a:spAutoFit/>
+          </a:bodyPr>
+          <a:lstStyle/>
+          <a:p>
+            <a:pPr algn="l">
+              <a:defRPr sz="1000" b="0">
+                <a:solidFill>
+                  <a:srgbClr val="64748B"/>
+                </a:solidFill>
+                <a:latin typeface="Malgun Gothic"/>
+              </a:defRPr>
+            </a:pPr>
+            <a:r>
+              <a:t>운영규정과 의제 결과를 같이 묶는 닫는 말</a:t>
+            </a:r>
+          </a:p>
+        </p:txBody>
+      </p:sp>
+      <p:cxnSp>
+        <p:nvCxnSpPr>
+          <p:cNvPr id="4" name="Connector 3"/>
+          <p:cNvCxnSpPr/>
+          <p:nvPr/>
+        </p:nvCxnSpPr>
+        <p:spPr>
+          <a:xfrm>
+            <a:off x="594360" y="1143000"/>
+            <a:ext cx="11018520" cy="0"/>
+          </a:xfrm>
+          <a:prstGeom prst="line">
+            <a:avLst/>
+          </a:prstGeom>
+          <a:ln w="10160">
+            <a:solidFill>
+              <a:srgbClr val="CBD5E1"/>
+            </a:solidFill>
+          </a:ln>
+        </p:spPr>
+        <p:style>
+          <a:lnRef idx="2">
+            <a:schemeClr val="accent1"/>
+          </a:lnRef>
+          <a:fillRef idx="0">
+            <a:schemeClr val="accent1"/>
+          </a:fillRef>
+          <a:effectRef idx="1">
+            <a:schemeClr val="accent1"/>
+          </a:effectRef>
+          <a:fontRef idx="minor">
+            <a:schemeClr val="tx1"/>
+          </a:fontRef>
+        </p:style>
+      </p:cxnSp>
+      <p:sp>
+        <p:nvSpPr>
+          <p:cNvPr id="5" name="TextBox 4"/>
+          <p:cNvSpPr txBox="1"/>
+          <p:nvPr/>
+        </p:nvSpPr>
+        <p:spPr>
+          <a:xfrm>
+            <a:off x="594360" y="6510528"/>
+            <a:ext cx="7772400" cy="201168"/>
+          </a:xfrm>
+          <a:prstGeom prst="rect">
+            <a:avLst/>
+          </a:prstGeom>
+          <a:noFill/>
+        </p:spPr>
+        <p:txBody>
+          <a:bodyPr wrap="square" lIns="73152" rIns="73152" tIns="36576" bIns="36576" anchor="t">
+            <a:spAutoFit/>
+          </a:bodyPr>
+          <a:lstStyle/>
+          <a:p>
+            <a:pPr algn="l">
+              <a:defRPr sz="800" b="0">
+                <a:solidFill>
+                  <a:srgbClr val="64748B"/>
+                </a:solidFill>
+                <a:latin typeface="Malgun Gothic"/>
+              </a:defRPr>
+            </a:pPr>
+            <a:r>
+              <a:t>기후시민회의 결론 도출과정 연결성 검증 · 10</a:t>
+            </a:r>
+          </a:p>
+        </p:txBody>
+      </p:sp>
+      <p:sp>
+        <p:nvSpPr>
+          <p:cNvPr id="6" name="Rounded Rectangle 5"/>
+          <p:cNvSpPr/>
+          <p:nvPr/>
+        </p:nvSpPr>
+        <p:spPr>
+          <a:xfrm>
+            <a:off x="1051560" y="1508760"/>
+            <a:ext cx="10058400" cy="2834640"/>
+          </a:xfrm>
+          <a:prstGeom prst="roundRect">
+            <a:avLst/>
+          </a:prstGeom>
+          <a:solidFill>
+            <a:srgbClr val="FFFFFF"/>
+          </a:solidFill>
+          <a:ln w="9525">
+            <a:solidFill>
+              <a:srgbClr val="0F766E"/>
+            </a:solidFill>
+          </a:ln>
+        </p:spPr>
+        <p:style>
+          <a:lnRef idx="1">
+            <a:schemeClr val="accent1"/>
+          </a:lnRef>
+          <a:fillRef idx="3">
+            <a:schemeClr val="accent1"/>
+          </a:fillRef>
+          <a:effectRef idx="2">
+            <a:schemeClr val="accent1"/>
+          </a:effectRef>
+          <a:fontRef idx="minor">
+            <a:schemeClr val="lt1"/>
+          </a:fontRef>
+        </p:style>
+        <p:txBody>
+          <a:bodyPr rtlCol="0" anchor="ctr"/>
+          <a:lstStyle/>
+          <a:p>
+            <a:pPr algn="ctr"/>
+          </a:p>
+        </p:txBody>
+      </p:sp>
+      <p:sp>
+        <p:nvSpPr>
+          <p:cNvPr id="7" name="TextBox 6"/>
+          <p:cNvSpPr txBox="1"/>
+          <p:nvPr/>
+        </p:nvSpPr>
+        <p:spPr>
+          <a:xfrm>
+            <a:off x="1600200" y="2057400"/>
+            <a:ext cx="8915400" cy="1143000"/>
+          </a:xfrm>
+          <a:prstGeom prst="rect">
+            <a:avLst/>
+          </a:prstGeom>
+          <a:noFill/>
+        </p:spPr>
+        <p:txBody>
+          <a:bodyPr wrap="square" lIns="73152" rIns="73152" tIns="36576" bIns="36576" anchor="ctr">
+            <a:spAutoFit/>
+          </a:bodyPr>
+          <a:lstStyle/>
+          <a:p>
+            <a:pPr algn="ctr">
+              <a:defRPr sz="2300" b="1">
+                <a:solidFill>
+                  <a:srgbClr val="1F2937"/>
+                </a:solidFill>
+                <a:latin typeface="Malgun Gothic"/>
+              </a:defRPr>
+            </a:pPr>
+            <a:r>
+              <a:t>“이번 결과는 토론 하나로 바로 결론을 낸 것이 아닙니다. 시민 제안과 조별 숙의가 기준과 후보를 만들었고, 기획참여단 투표가 운영규정과 의제의 방향을 확인했으며, 겹치는 후보는 통합해서 오늘의 결론으로 정리했습니다.”</a:t>
+            </a:r>
+          </a:p>
+        </p:txBody>
+      </p:sp>
+      <p:sp>
+        <p:nvSpPr>
+          <p:cNvPr id="8" name="TextBox 7"/>
+          <p:cNvSpPr txBox="1"/>
+          <p:nvPr/>
+        </p:nvSpPr>
+        <p:spPr>
+          <a:xfrm>
+            <a:off x="1508760" y="4846320"/>
+            <a:ext cx="9326880" cy="384048"/>
+          </a:xfrm>
+          <a:prstGeom prst="rect">
+            <a:avLst/>
+          </a:prstGeom>
+          <a:noFill/>
+        </p:spPr>
+        <p:txBody>
+          <a:bodyPr wrap="square" lIns="73152" rIns="73152" tIns="36576" bIns="36576" anchor="t">
+            <a:spAutoFit/>
+          </a:bodyPr>
+          <a:lstStyle/>
+          <a:p>
+            <a:pPr algn="ctr">
+              <a:defRPr sz="1500" b="0">
+                <a:solidFill>
+                  <a:srgbClr val="64748B"/>
+                </a:solidFill>
+                <a:latin typeface="Malgun Gothic"/>
+              </a:defRPr>
+            </a:pPr>
+            <a:r>
+              <a:t>단, 데이터 반영 범위는 정직하게 말한다: A-only는 아니지만, partial/gap 3건은 별도 재확인 대상이다.</a:t>
+            </a:r>
+          </a:p>
+        </p:txBody>
+      </p:sp>
+    </p:spTree>
+  </p:cSld>
+  <p:clrMapOvr>
+    <a:masterClrMapping/>
+  </p:clrMapOvr>
+</p:sld>
+</file>
+
 <file path=ppt/slides/slide2.xml><?xml version="1.0" encoding="utf-8"?>
 <p:sld xmlns:a="http://schemas.openxmlformats.org/drawingml/2006/main" xmlns:p="http://schemas.openxmlformats.org/presentationml/2006/main" xmlns:r="http://schemas.openxmlformats.org/officeDocument/2006/relationships">
   <p:cSld>
@@ -10162,7 +10449,7 @@
               </a:defRPr>
             </a:pPr>
             <a:r>
-              <a:t>5. 의제 3개: 확정·통합·미확정 슬롯을 분리</a:t>
+              <a:t>5. 의제 3개: 현재 발표덱 기준</a:t>
             </a:r>
           </a:p>
         </p:txBody>
@@ -10198,7 +10485,7 @@
               </a:defRPr>
             </a:pPr>
             <a:r>
-              <a:t>세 번째는 현재 증거상 확정명이 아니라 새 의제 슬롯</a:t>
+              <a:t>상위 숙의의제 PPTX는 3개 의제를 별도 슬라이드로 제시</a:t>
             </a:r>
           </a:p>
         </p:txBody>
@@ -10395,7 +10682,7 @@
               </a:defRPr>
             </a:pPr>
             <a:r>
-              <a:t>적응</a:t>
+              <a:t>1위</a:t>
             </a:r>
           </a:p>
         </p:txBody>
@@ -10431,7 +10718,7 @@
               </a:defRPr>
             </a:pPr>
             <a:r>
-              <a:t>생애주기 탄소중립 교육 및 시민의식 개선</a:t>
+              <a:t>전 생애주기 탄소중립 교육 체계 구축</a:t>
             </a:r>
           </a:p>
         </p:txBody>
@@ -10459,7 +10746,7 @@
           <a:lstStyle/>
           <a:p>
             <a:pPr algn="l">
-              <a:defRPr sz="1100" b="1">
+              <a:defRPr sz="1000" b="1">
                 <a:solidFill>
                   <a:srgbClr val="0F766E"/>
                 </a:solidFill>
@@ -10467,7 +10754,7 @@
               </a:defRPr>
             </a:pPr>
             <a:r>
-              <a:t>확정 설명 가능</a:t>
+              <a:t>현재 숙의의제 발표덱에 별도 의제로 제시 · deck 13쪽</a:t>
             </a:r>
           </a:p>
         </p:txBody>
@@ -10503,7 +10790,7 @@
               </a:defRPr>
             </a:pPr>
             <a:r>
-              <a:t>- 사전 접수와 조별 숙의에서 교육·시민참여 맥락이 반복됨</a:t>
+              <a:t>- 사전 접수와 조별 숙의에서 교육 필요성이 반복됨</a:t>
             </a:r>
           </a:p>
           <a:p>
@@ -10516,7 +10803,7 @@
               </a:defRPr>
             </a:pPr>
             <a:r>
-              <a:t>- 교육 의제가 평가 1위, 시민참여 의제가 공동 2위로 확인됨</a:t>
+              <a:t>- 투표에서 가장 앞선 후보로 확인됨</a:t>
             </a:r>
           </a:p>
           <a:p>
@@ -10529,7 +10816,7 @@
               </a:defRPr>
             </a:pPr>
             <a:r>
-              <a:t>- 발표 시나리오에서 시민참여를 교육 의제에 통합해 적응 분과 의제로 설명함</a:t>
+              <a:t>- 현재 숙의의제 발표덱 13쪽에서 별도 의제로 설명됨</a:t>
             </a:r>
           </a:p>
         </p:txBody>
@@ -10543,6 +10830,266 @@
         <p:spPr>
           <a:xfrm>
             <a:off x="4480560" y="1417320"/>
+            <a:ext cx="3337560" cy="4206240"/>
+          </a:xfrm>
+          <a:prstGeom prst="roundRect">
+            <a:avLst/>
+          </a:prstGeom>
+          <a:solidFill>
+            <a:srgbClr val="FFFFFF"/>
+          </a:solidFill>
+          <a:ln w="9525">
+            <a:solidFill>
+              <a:srgbClr val="4F46E5"/>
+            </a:solidFill>
+          </a:ln>
+        </p:spPr>
+        <p:style>
+          <a:lnRef idx="1">
+            <a:schemeClr val="accent1"/>
+          </a:lnRef>
+          <a:fillRef idx="3">
+            <a:schemeClr val="accent1"/>
+          </a:fillRef>
+          <a:effectRef idx="2">
+            <a:schemeClr val="accent1"/>
+          </a:effectRef>
+          <a:fontRef idx="minor">
+            <a:schemeClr val="lt1"/>
+          </a:fontRef>
+        </p:style>
+        <p:txBody>
+          <a:bodyPr rtlCol="0" anchor="ctr"/>
+          <a:lstStyle/>
+          <a:p>
+            <a:pPr algn="ctr"/>
+          </a:p>
+        </p:txBody>
+      </p:sp>
+      <p:sp>
+        <p:nvSpPr>
+          <p:cNvPr id="13" name="Rounded Rectangle 12"/>
+          <p:cNvSpPr/>
+          <p:nvPr/>
+        </p:nvSpPr>
+        <p:spPr>
+          <a:xfrm>
+            <a:off x="4709160" y="1664208"/>
+            <a:ext cx="868680" cy="329184"/>
+          </a:xfrm>
+          <a:prstGeom prst="roundRect">
+            <a:avLst/>
+          </a:prstGeom>
+          <a:solidFill>
+            <a:srgbClr val="4F46E5"/>
+          </a:solidFill>
+          <a:ln w="9525">
+            <a:solidFill>
+              <a:srgbClr val="4F46E5"/>
+            </a:solidFill>
+          </a:ln>
+        </p:spPr>
+        <p:style>
+          <a:lnRef idx="1">
+            <a:schemeClr val="accent1"/>
+          </a:lnRef>
+          <a:fillRef idx="3">
+            <a:schemeClr val="accent1"/>
+          </a:fillRef>
+          <a:effectRef idx="2">
+            <a:schemeClr val="accent1"/>
+          </a:effectRef>
+          <a:fontRef idx="minor">
+            <a:schemeClr val="lt1"/>
+          </a:fontRef>
+        </p:style>
+        <p:txBody>
+          <a:bodyPr rtlCol="0" anchor="ctr"/>
+          <a:lstStyle/>
+          <a:p>
+            <a:pPr algn="ctr"/>
+          </a:p>
+        </p:txBody>
+      </p:sp>
+      <p:sp>
+        <p:nvSpPr>
+          <p:cNvPr id="14" name="TextBox 13"/>
+          <p:cNvSpPr txBox="1"/>
+          <p:nvPr/>
+        </p:nvSpPr>
+        <p:spPr>
+          <a:xfrm>
+            <a:off x="4736592" y="1714500"/>
+            <a:ext cx="813815" cy="219456"/>
+          </a:xfrm>
+          <a:prstGeom prst="rect">
+            <a:avLst/>
+          </a:prstGeom>
+          <a:noFill/>
+        </p:spPr>
+        <p:txBody>
+          <a:bodyPr wrap="square" lIns="73152" rIns="73152" tIns="36576" bIns="36576" anchor="t">
+            <a:spAutoFit/>
+          </a:bodyPr>
+          <a:lstStyle/>
+          <a:p>
+            <a:pPr algn="ctr">
+              <a:defRPr sz="1000" b="1">
+                <a:solidFill>
+                  <a:srgbClr val="FFFFFF"/>
+                </a:solidFill>
+                <a:latin typeface="Malgun Gothic"/>
+              </a:defRPr>
+            </a:pPr>
+            <a:r>
+              <a:t>공동 2위</a:t>
+            </a:r>
+          </a:p>
+        </p:txBody>
+      </p:sp>
+      <p:sp>
+        <p:nvSpPr>
+          <p:cNvPr id="15" name="TextBox 14"/>
+          <p:cNvSpPr txBox="1"/>
+          <p:nvPr/>
+        </p:nvSpPr>
+        <p:spPr>
+          <a:xfrm>
+            <a:off x="4709160" y="2148840"/>
+            <a:ext cx="2788920" cy="713232"/>
+          </a:xfrm>
+          <a:prstGeom prst="rect">
+            <a:avLst/>
+          </a:prstGeom>
+          <a:noFill/>
+        </p:spPr>
+        <p:txBody>
+          <a:bodyPr wrap="square" lIns="73152" rIns="73152" tIns="36576" bIns="36576" anchor="t">
+            <a:spAutoFit/>
+          </a:bodyPr>
+          <a:lstStyle/>
+          <a:p>
+            <a:pPr algn="l">
+              <a:defRPr sz="1600" b="1">
+                <a:solidFill>
+                  <a:srgbClr val="1F2937"/>
+                </a:solidFill>
+                <a:latin typeface="Malgun Gothic"/>
+              </a:defRPr>
+            </a:pPr>
+            <a:r>
+              <a:t>시민의식 개선 · 참여 활성화</a:t>
+            </a:r>
+          </a:p>
+        </p:txBody>
+      </p:sp>
+      <p:sp>
+        <p:nvSpPr>
+          <p:cNvPr id="16" name="TextBox 15"/>
+          <p:cNvSpPr txBox="1"/>
+          <p:nvPr/>
+        </p:nvSpPr>
+        <p:spPr>
+          <a:xfrm>
+            <a:off x="4709160" y="2944368"/>
+            <a:ext cx="2834640" cy="256032"/>
+          </a:xfrm>
+          <a:prstGeom prst="rect">
+            <a:avLst/>
+          </a:prstGeom>
+          <a:noFill/>
+        </p:spPr>
+        <p:txBody>
+          <a:bodyPr wrap="square" lIns="73152" rIns="73152" tIns="36576" bIns="36576" anchor="t">
+            <a:spAutoFit/>
+          </a:bodyPr>
+          <a:lstStyle/>
+          <a:p>
+            <a:pPr algn="l">
+              <a:defRPr sz="1000" b="1">
+                <a:solidFill>
+                  <a:srgbClr val="4F46E5"/>
+                </a:solidFill>
+                <a:latin typeface="Malgun Gothic"/>
+              </a:defRPr>
+            </a:pPr>
+            <a:r>
+              <a:t>현재 숙의의제 발표덱에 별도 의제로 제시 · deck 14쪽</a:t>
+            </a:r>
+          </a:p>
+        </p:txBody>
+      </p:sp>
+      <p:sp>
+        <p:nvSpPr>
+          <p:cNvPr id="17" name="TextBox 16"/>
+          <p:cNvSpPr txBox="1"/>
+          <p:nvPr/>
+        </p:nvSpPr>
+        <p:spPr>
+          <a:xfrm>
+            <a:off x="4709160" y="3429000"/>
+            <a:ext cx="2834640" cy="1325880"/>
+          </a:xfrm>
+          <a:prstGeom prst="rect">
+            <a:avLst/>
+          </a:prstGeom>
+          <a:noFill/>
+        </p:spPr>
+        <p:txBody>
+          <a:bodyPr wrap="square" lIns="73152" rIns="73152" tIns="36576" bIns="36576" anchor="t">
+            <a:spAutoFit/>
+          </a:bodyPr>
+          <a:lstStyle/>
+          <a:p>
+            <a:pPr algn="l">
+              <a:defRPr sz="800" b="0">
+                <a:solidFill>
+                  <a:srgbClr val="64748B"/>
+                </a:solidFill>
+                <a:latin typeface="Malgun Gothic"/>
+              </a:defRPr>
+            </a:pPr>
+            <a:r>
+              <a:t>- 시민의식 개선과 참여 활성화 맥락이 교육·거버넌스 논의와 연결됨</a:t>
+            </a:r>
+          </a:p>
+          <a:p>
+            <a:pPr algn="l">
+              <a:defRPr sz="800" b="0">
+                <a:solidFill>
+                  <a:srgbClr val="64748B"/>
+                </a:solidFill>
+                <a:latin typeface="Malgun Gothic"/>
+              </a:defRPr>
+            </a:pPr>
+            <a:r>
+              <a:t>- 투표에서 공동 2위권 후보로 확인됨</a:t>
+            </a:r>
+          </a:p>
+          <a:p>
+            <a:pPr algn="l">
+              <a:defRPr sz="800" b="0">
+                <a:solidFill>
+                  <a:srgbClr val="64748B"/>
+                </a:solidFill>
+                <a:latin typeface="Malgun Gothic"/>
+              </a:defRPr>
+            </a:pPr>
+            <a:r>
+              <a:t>- 현재 숙의의제 발표덱 14쪽에서 별도 의제로 설명됨</a:t>
+            </a:r>
+          </a:p>
+        </p:txBody>
+      </p:sp>
+      <p:sp>
+        <p:nvSpPr>
+          <p:cNvPr id="18" name="Rounded Rectangle 17"/>
+          <p:cNvSpPr/>
+          <p:nvPr/>
+        </p:nvSpPr>
+        <p:spPr>
+          <a:xfrm>
+            <a:off x="8275320" y="1417320"/>
             <a:ext cx="3337560" cy="4206240"/>
           </a:xfrm>
           <a:prstGeom prst="roundRect">
@@ -10581,13 +11128,13 @@
       </p:sp>
       <p:sp>
         <p:nvSpPr>
-          <p:cNvPr id="13" name="Rounded Rectangle 12"/>
+          <p:cNvPr id="19" name="Rounded Rectangle 18"/>
           <p:cNvSpPr/>
           <p:nvPr/>
         </p:nvSpPr>
         <p:spPr>
           <a:xfrm>
-            <a:off x="4709160" y="1664208"/>
+            <a:off x="8503920" y="1664208"/>
             <a:ext cx="868680" cy="329184"/>
           </a:xfrm>
           <a:prstGeom prst="roundRect">
@@ -10626,13 +11173,13 @@
       </p:sp>
       <p:sp>
         <p:nvSpPr>
-          <p:cNvPr id="14" name="TextBox 13"/>
-          <p:cNvSpPr txBox="1"/>
-          <p:nvPr/>
-        </p:nvSpPr>
-        <p:spPr>
-          <a:xfrm>
-            <a:off x="4736592" y="1714500"/>
+          <p:cNvPr id="20" name="TextBox 19"/>
+          <p:cNvSpPr txBox="1"/>
+          <p:nvPr/>
+        </p:nvSpPr>
+        <p:spPr>
+          <a:xfrm>
+            <a:off x="8531352" y="1714500"/>
             <a:ext cx="813815" cy="219456"/>
           </a:xfrm>
           <a:prstGeom prst="rect">
@@ -10655,20 +11202,20 @@
               </a:defRPr>
             </a:pPr>
             <a:r>
-              <a:t>감축1</a:t>
-            </a:r>
-          </a:p>
-        </p:txBody>
-      </p:sp>
-      <p:sp>
-        <p:nvSpPr>
-          <p:cNvPr id="15" name="TextBox 14"/>
-          <p:cNvSpPr txBox="1"/>
-          <p:nvPr/>
-        </p:nvSpPr>
-        <p:spPr>
-          <a:xfrm>
-            <a:off x="4709160" y="2148840"/>
+              <a:t>공동 2위</a:t>
+            </a:r>
+          </a:p>
+        </p:txBody>
+      </p:sp>
+      <p:sp>
+        <p:nvSpPr>
+          <p:cNvPr id="21" name="TextBox 20"/>
+          <p:cNvSpPr txBox="1"/>
+          <p:nvPr/>
+        </p:nvSpPr>
+        <p:spPr>
+          <a:xfrm>
+            <a:off x="8503920" y="2148840"/>
             <a:ext cx="2788920" cy="713232"/>
           </a:xfrm>
           <a:prstGeom prst="rect">
@@ -10691,20 +11238,20 @@
               </a:defRPr>
             </a:pPr>
             <a:r>
-              <a:t>자원순환·생활폐기물 감축</a:t>
-            </a:r>
-          </a:p>
-        </p:txBody>
-      </p:sp>
-      <p:sp>
-        <p:nvSpPr>
-          <p:cNvPr id="16" name="TextBox 15"/>
-          <p:cNvSpPr txBox="1"/>
-          <p:nvPr/>
-        </p:nvSpPr>
-        <p:spPr>
-          <a:xfrm>
-            <a:off x="4709160" y="2944368"/>
+              <a:t>자원순환 · 생활폐기물 감축</a:t>
+            </a:r>
+          </a:p>
+        </p:txBody>
+      </p:sp>
+      <p:sp>
+        <p:nvSpPr>
+          <p:cNvPr id="22" name="TextBox 21"/>
+          <p:cNvSpPr txBox="1"/>
+          <p:nvPr/>
+        </p:nvSpPr>
+        <p:spPr>
+          <a:xfrm>
+            <a:off x="8503920" y="2944368"/>
             <a:ext cx="2834640" cy="256032"/>
           </a:xfrm>
           <a:prstGeom prst="rect">
@@ -10719,7 +11266,7 @@
           <a:lstStyle/>
           <a:p>
             <a:pPr algn="l">
-              <a:defRPr sz="1100" b="1">
+              <a:defRPr sz="1000" b="1">
                 <a:solidFill>
                   <a:srgbClr val="0891B2"/>
                 </a:solidFill>
@@ -10727,20 +11274,20 @@
               </a:defRPr>
             </a:pPr>
             <a:r>
-              <a:t>확정 설명 가능</a:t>
-            </a:r>
-          </a:p>
-        </p:txBody>
-      </p:sp>
-      <p:sp>
-        <p:nvSpPr>
-          <p:cNvPr id="17" name="TextBox 16"/>
-          <p:cNvSpPr txBox="1"/>
-          <p:nvPr/>
-        </p:nvSpPr>
-        <p:spPr>
-          <a:xfrm>
-            <a:off x="4709160" y="3429000"/>
+              <a:t>현재 숙의의제 발표덱에 별도 의제로 제시 · deck 15쪽</a:t>
+            </a:r>
+          </a:p>
+        </p:txBody>
+      </p:sp>
+      <p:sp>
+        <p:nvSpPr>
+          <p:cNvPr id="23" name="TextBox 22"/>
+          <p:cNvSpPr txBox="1"/>
+          <p:nvPr/>
+        </p:nvSpPr>
+        <p:spPr>
+          <a:xfrm>
+            <a:off x="8503920" y="3429000"/>
             <a:ext cx="2834640" cy="1325880"/>
           </a:xfrm>
           <a:prstGeom prst="rect">
@@ -10763,7 +11310,7 @@
               </a:defRPr>
             </a:pPr>
             <a:r>
-              <a:t>- 사전 접수 분석에서 소비·생활양식과 자원순환 흐름이 크게 나타남</a:t>
+              <a:t>- A조 자원순환형 배달 문화와 B조 생활폐기물 감축 논의가 만남</a:t>
             </a:r>
           </a:p>
           <a:p>
@@ -10776,7 +11323,7 @@
               </a:defRPr>
             </a:pPr>
             <a:r>
-              <a:t>- A조 자원순환형 배달 문화와 B조 생활폐기물 감축 논의를 통합함</a:t>
+              <a:t>- 투표에서 공동 2위권 후보로 확인됨</a:t>
             </a:r>
           </a:p>
           <a:p>
@@ -10789,267 +11336,7 @@
               </a:defRPr>
             </a:pPr>
             <a:r>
-              <a:t>- 평가 결과 공동 2위권으로 확인되어 감축1 분과 의제로 설명함</a:t>
-            </a:r>
-          </a:p>
-        </p:txBody>
-      </p:sp>
-      <p:sp>
-        <p:nvSpPr>
-          <p:cNvPr id="18" name="Rounded Rectangle 17"/>
-          <p:cNvSpPr/>
-          <p:nvPr/>
-        </p:nvSpPr>
-        <p:spPr>
-          <a:xfrm>
-            <a:off x="8275320" y="1417320"/>
-            <a:ext cx="3337560" cy="4206240"/>
-          </a:xfrm>
-          <a:prstGeom prst="roundRect">
-            <a:avLst/>
-          </a:prstGeom>
-          <a:solidFill>
-            <a:srgbClr val="FFFFFF"/>
-          </a:solidFill>
-          <a:ln w="9525">
-            <a:solidFill>
-              <a:srgbClr val="BE123C"/>
-            </a:solidFill>
-          </a:ln>
-        </p:spPr>
-        <p:style>
-          <a:lnRef idx="1">
-            <a:schemeClr val="accent1"/>
-          </a:lnRef>
-          <a:fillRef idx="3">
-            <a:schemeClr val="accent1"/>
-          </a:fillRef>
-          <a:effectRef idx="2">
-            <a:schemeClr val="accent1"/>
-          </a:effectRef>
-          <a:fontRef idx="minor">
-            <a:schemeClr val="lt1"/>
-          </a:fontRef>
-        </p:style>
-        <p:txBody>
-          <a:bodyPr rtlCol="0" anchor="ctr"/>
-          <a:lstStyle/>
-          <a:p>
-            <a:pPr algn="ctr"/>
-          </a:p>
-        </p:txBody>
-      </p:sp>
-      <p:sp>
-        <p:nvSpPr>
-          <p:cNvPr id="19" name="Rounded Rectangle 18"/>
-          <p:cNvSpPr/>
-          <p:nvPr/>
-        </p:nvSpPr>
-        <p:spPr>
-          <a:xfrm>
-            <a:off x="8503920" y="1664208"/>
-            <a:ext cx="868680" cy="329184"/>
-          </a:xfrm>
-          <a:prstGeom prst="roundRect">
-            <a:avLst/>
-          </a:prstGeom>
-          <a:solidFill>
-            <a:srgbClr val="BE123C"/>
-          </a:solidFill>
-          <a:ln w="9525">
-            <a:solidFill>
-              <a:srgbClr val="BE123C"/>
-            </a:solidFill>
-          </a:ln>
-        </p:spPr>
-        <p:style>
-          <a:lnRef idx="1">
-            <a:schemeClr val="accent1"/>
-          </a:lnRef>
-          <a:fillRef idx="3">
-            <a:schemeClr val="accent1"/>
-          </a:fillRef>
-          <a:effectRef idx="2">
-            <a:schemeClr val="accent1"/>
-          </a:effectRef>
-          <a:fontRef idx="minor">
-            <a:schemeClr val="lt1"/>
-          </a:fontRef>
-        </p:style>
-        <p:txBody>
-          <a:bodyPr rtlCol="0" anchor="ctr"/>
-          <a:lstStyle/>
-          <a:p>
-            <a:pPr algn="ctr"/>
-          </a:p>
-        </p:txBody>
-      </p:sp>
-      <p:sp>
-        <p:nvSpPr>
-          <p:cNvPr id="20" name="TextBox 19"/>
-          <p:cNvSpPr txBox="1"/>
-          <p:nvPr/>
-        </p:nvSpPr>
-        <p:spPr>
-          <a:xfrm>
-            <a:off x="8531352" y="1714500"/>
-            <a:ext cx="813815" cy="219456"/>
-          </a:xfrm>
-          <a:prstGeom prst="rect">
-            <a:avLst/>
-          </a:prstGeom>
-          <a:noFill/>
-        </p:spPr>
-        <p:txBody>
-          <a:bodyPr wrap="square" lIns="73152" rIns="73152" tIns="36576" bIns="36576" anchor="t">
-            <a:spAutoFit/>
-          </a:bodyPr>
-          <a:lstStyle/>
-          <a:p>
-            <a:pPr algn="ctr">
-              <a:defRPr sz="1000" b="1">
-                <a:solidFill>
-                  <a:srgbClr val="FFFFFF"/>
-                </a:solidFill>
-                <a:latin typeface="Malgun Gothic"/>
-              </a:defRPr>
-            </a:pPr>
-            <a:r>
-              <a:t>감축2</a:t>
-            </a:r>
-          </a:p>
-        </p:txBody>
-      </p:sp>
-      <p:sp>
-        <p:nvSpPr>
-          <p:cNvPr id="21" name="TextBox 20"/>
-          <p:cNvSpPr txBox="1"/>
-          <p:nvPr/>
-        </p:nvSpPr>
-        <p:spPr>
-          <a:xfrm>
-            <a:off x="8503920" y="2148840"/>
-            <a:ext cx="2788920" cy="713232"/>
-          </a:xfrm>
-          <a:prstGeom prst="rect">
-            <a:avLst/>
-          </a:prstGeom>
-          <a:noFill/>
-        </p:spPr>
-        <p:txBody>
-          <a:bodyPr wrap="square" lIns="73152" rIns="73152" tIns="36576" bIns="36576" anchor="t">
-            <a:spAutoFit/>
-          </a:bodyPr>
-          <a:lstStyle/>
-          <a:p>
-            <a:pPr algn="l">
-              <a:defRPr sz="1600" b="1">
-                <a:solidFill>
-                  <a:srgbClr val="1F2937"/>
-                </a:solidFill>
-                <a:latin typeface="Malgun Gothic"/>
-              </a:defRPr>
-            </a:pPr>
-            <a:r>
-              <a:t>새로운 의제 슬롯</a:t>
-            </a:r>
-          </a:p>
-        </p:txBody>
-      </p:sp>
-      <p:sp>
-        <p:nvSpPr>
-          <p:cNvPr id="22" name="TextBox 21"/>
-          <p:cNvSpPr txBox="1"/>
-          <p:nvPr/>
-        </p:nvSpPr>
-        <p:spPr>
-          <a:xfrm>
-            <a:off x="8503920" y="2944368"/>
-            <a:ext cx="2834640" cy="256032"/>
-          </a:xfrm>
-          <a:prstGeom prst="rect">
-            <a:avLst/>
-          </a:prstGeom>
-          <a:noFill/>
-        </p:spPr>
-        <p:txBody>
-          <a:bodyPr wrap="square" lIns="73152" rIns="73152" tIns="36576" bIns="36576" anchor="t">
-            <a:spAutoFit/>
-          </a:bodyPr>
-          <a:lstStyle/>
-          <a:p>
-            <a:pPr algn="l">
-              <a:defRPr sz="1100" b="1">
-                <a:solidFill>
-                  <a:srgbClr val="BE123C"/>
-                </a:solidFill>
-                <a:latin typeface="Malgun Gothic"/>
-              </a:defRPr>
-            </a:pPr>
-            <a:r>
-              <a:t>확정명 증거 부족</a:t>
-            </a:r>
-          </a:p>
-        </p:txBody>
-      </p:sp>
-      <p:sp>
-        <p:nvSpPr>
-          <p:cNvPr id="23" name="TextBox 22"/>
-          <p:cNvSpPr txBox="1"/>
-          <p:nvPr/>
-        </p:nvSpPr>
-        <p:spPr>
-          <a:xfrm>
-            <a:off x="8503920" y="3429000"/>
-            <a:ext cx="2834640" cy="1325880"/>
-          </a:xfrm>
-          <a:prstGeom prst="rect">
-            <a:avLst/>
-          </a:prstGeom>
-          <a:noFill/>
-        </p:spPr>
-        <p:txBody>
-          <a:bodyPr wrap="square" lIns="73152" rIns="73152" tIns="36576" bIns="36576" anchor="t">
-            <a:spAutoFit/>
-          </a:bodyPr>
-          <a:lstStyle/>
-          <a:p>
-            <a:pPr algn="l">
-              <a:defRPr sz="800" b="0">
-                <a:solidFill>
-                  <a:srgbClr val="64748B"/>
-                </a:solidFill>
-                <a:latin typeface="Malgun Gothic"/>
-              </a:defRPr>
-            </a:pPr>
-            <a:r>
-              <a:t>- 시민의식 개선 후보가 교육 의제에 통합되며 세 번째 자리가 열림</a:t>
-            </a:r>
-          </a:p>
-          <a:p>
-            <a:pPr algn="l">
-              <a:defRPr sz="800" b="0">
-                <a:solidFill>
-                  <a:srgbClr val="64748B"/>
-                </a:solidFill>
-                <a:latin typeface="Malgun Gothic"/>
-              </a:defRPr>
-            </a:pPr>
-            <a:r>
-              <a:t>- 발표 시나리오 7쪽·10쪽에 7.4 당일 확정 후 수정 표시가 남아 있음</a:t>
-            </a:r>
-          </a:p>
-          <a:p>
-            <a:pPr algn="l">
-              <a:defRPr sz="800" b="0">
-                <a:solidFill>
-                  <a:srgbClr val="64748B"/>
-                </a:solidFill>
-                <a:latin typeface="Malgun Gothic"/>
-              </a:defRPr>
-            </a:pPr>
-            <a:r>
-              <a:t>- 현재 repo 증거만으로는 별도 최종 의제명을 단정할 수 없음</a:t>
+              <a:t>- 현재 숙의의제 발표덱 15쪽에서 별도 의제로 설명됨</a:t>
             </a:r>
           </a:p>
         </p:txBody>
@@ -11085,7 +11372,7 @@
               </a:defRPr>
             </a:pPr>
             <a:r>
-              <a:t>이 구분이 있어야 `없는 확정명`을 만들어내지 않으면서도 세 방향의 도출과정을 보여줄 수 있다.</a:t>
+              <a:t>현재 숙의의제 발표덱 기준으로는 교육, 시민의식·참여, 자원순환이 각각 의제 3개로 보인다.</a:t>
             </a:r>
           </a:p>
         </p:txBody>
@@ -11740,7 +12027,7 @@
               </a:defRPr>
             </a:pPr>
             <a:r>
-              <a:t>교육·시민참여</a:t>
+              <a:t>교육</a:t>
             </a:r>
           </a:p>
         </p:txBody>
@@ -11821,7 +12108,7 @@
               </a:defRPr>
             </a:pPr>
             <a:r>
-              <a:t>교육 의제에 시민의식 개선 후보 통합</a:t>
+              <a:t>전 생애주기 탄소중립 교육 체계 구축</a:t>
             </a:r>
           </a:p>
         </p:txBody>
@@ -11902,7 +12189,7 @@
               </a:defRPr>
             </a:pPr>
             <a:r>
-              <a:t>1위 + 공동 2위</a:t>
+              <a:t>1위</a:t>
             </a:r>
           </a:p>
         </p:txBody>
@@ -11983,7 +12270,7 @@
               </a:defRPr>
             </a:pPr>
             <a:r>
-              <a:t>10건 + 12건</a:t>
+              <a:t>10건</a:t>
             </a:r>
           </a:p>
         </p:txBody>
@@ -12064,7 +12351,7 @@
               </a:defRPr>
             </a:pPr>
             <a:r>
-              <a:t>교육 체계와 참여 활성화를 하나로 설명</a:t>
+              <a:t>학습·다음세대·지역교육 논의가 투표 결과로 연결</a:t>
             </a:r>
           </a:p>
         </p:txBody>
@@ -12145,7 +12432,7 @@
               </a:defRPr>
             </a:pPr>
             <a:r>
-              <a:t>자원순환·폐기물</a:t>
+              <a:t>시민의식·참여</a:t>
             </a:r>
           </a:p>
         </p:txBody>
@@ -12226,7 +12513,7 @@
               </a:defRPr>
             </a:pPr>
             <a:r>
-              <a:t>배달 문화와 생활폐기물 감축 통합</a:t>
+              <a:t>시민의식 개선 및 참여 활성화</a:t>
             </a:r>
           </a:p>
         </p:txBody>
@@ -12307,7 +12594,7 @@
               </a:defRPr>
             </a:pPr>
             <a:r>
-              <a:t>공동 2위권</a:t>
+              <a:t>공동 2위</a:t>
             </a:r>
           </a:p>
         </p:txBody>
@@ -12469,7 +12756,7 @@
               </a:defRPr>
             </a:pPr>
             <a:r>
-              <a:t>소비·생활양식 논의를 감축1 의제로 연결</a:t>
+              <a:t>일상 행동과 참여 활성화 논의가 별도 의제로 연결</a:t>
             </a:r>
           </a:p>
         </p:txBody>
@@ -12550,7 +12837,7 @@
               </a:defRPr>
             </a:pPr>
             <a:r>
-              <a:t>감축2 새 의제</a:t>
+              <a:t>자원순환·폐기물</a:t>
             </a:r>
           </a:p>
         </p:txBody>
@@ -12631,7 +12918,7 @@
               </a:defRPr>
             </a:pPr>
             <a:r>
-              <a:t>새 의제 슬롯</a:t>
+              <a:t>배달 문화와 생활폐기물 감축 통합</a:t>
             </a:r>
           </a:p>
         </p:txBody>
@@ -12712,7 +12999,7 @@
               </a:defRPr>
             </a:pPr>
             <a:r>
-              <a:t>추가 필요</a:t>
+              <a:t>공동 2위권</a:t>
             </a:r>
           </a:p>
         </p:txBody>
@@ -12793,7 +13080,7 @@
               </a:defRPr>
             </a:pPr>
             <a:r>
-              <a:t>추가 필요</a:t>
+              <a:t>12건</a:t>
             </a:r>
           </a:p>
         </p:txBody>
@@ -12874,7 +13161,7 @@
               </a:defRPr>
             </a:pPr>
             <a:r>
-              <a:t>현재 파일만으로 확정명 단정 불가</a:t>
+              <a:t>소비·생활양식 논의를 감축1 의제로 연결</a:t>
             </a:r>
           </a:p>
         </p:txBody>
@@ -12947,7 +13234,7 @@
           <a:lstStyle/>
           <a:p>
             <a:pPr algn="ctr">
-              <a:defRPr sz="1400" b="1">
+              <a:defRPr sz="1300" b="1">
                 <a:solidFill>
                   <a:srgbClr val="B45309"/>
                 </a:solidFill>
@@ -12955,7 +13242,7 @@
               </a:defRPr>
             </a:pPr>
             <a:r>
-              <a:t>권고: 본 발표에서는 1·2번을 확정 연결로, 3번은 `새 의제 확정 근거 필요`로 말한다.</a:t>
+              <a:t>권고: 3개 의제는 현재 숙의의제 발표덱 기준으로 말하고, v6 통합 시나리오 차이는 다음 장에서 별도 설명한다.</a:t>
             </a:r>
           </a:p>
         </p:txBody>
@@ -13017,7 +13304,7 @@
               </a:defRPr>
             </a:pPr>
             <a:r>
-              <a:t>7. 남은 검증 게이트</a:t>
+              <a:t>7. 자료 간 차이: v6 통합 시나리오</a:t>
             </a:r>
           </a:p>
         </p:txBody>
@@ -13053,7 +13340,7 @@
               </a:defRPr>
             </a:pPr>
             <a:r>
-              <a:t>완전 반영 완료라고 말하기 전에 닫아야 할 항목</a:t>
+              <a:t>교육+시민참여 통합과 감축2 새 슬롯은 별도 caveat</a:t>
             </a:r>
           </a:p>
         </p:txBody>
@@ -13137,8 +13424,502 @@
         </p:nvSpPr>
         <p:spPr>
           <a:xfrm>
-            <a:off x="822960" y="1508760"/>
-            <a:ext cx="10424160" cy="841248"/>
+            <a:off x="685800" y="1417320"/>
+            <a:ext cx="3337560" cy="3246120"/>
+          </a:xfrm>
+          <a:prstGeom prst="roundRect">
+            <a:avLst/>
+          </a:prstGeom>
+          <a:solidFill>
+            <a:srgbClr val="FFFFFF"/>
+          </a:solidFill>
+          <a:ln w="9525">
+            <a:solidFill>
+              <a:srgbClr val="0F766E"/>
+            </a:solidFill>
+          </a:ln>
+        </p:spPr>
+        <p:style>
+          <a:lnRef idx="1">
+            <a:schemeClr val="accent1"/>
+          </a:lnRef>
+          <a:fillRef idx="3">
+            <a:schemeClr val="accent1"/>
+          </a:fillRef>
+          <a:effectRef idx="2">
+            <a:schemeClr val="accent1"/>
+          </a:effectRef>
+          <a:fontRef idx="minor">
+            <a:schemeClr val="lt1"/>
+          </a:fontRef>
+        </p:style>
+        <p:txBody>
+          <a:bodyPr rtlCol="0" anchor="ctr"/>
+          <a:lstStyle/>
+          <a:p>
+            <a:pPr algn="ctr"/>
+          </a:p>
+        </p:txBody>
+      </p:sp>
+      <p:sp>
+        <p:nvSpPr>
+          <p:cNvPr id="7" name="Rounded Rectangle 6"/>
+          <p:cNvSpPr/>
+          <p:nvPr/>
+        </p:nvSpPr>
+        <p:spPr>
+          <a:xfrm>
+            <a:off x="914400" y="1664208"/>
+            <a:ext cx="868680" cy="329184"/>
+          </a:xfrm>
+          <a:prstGeom prst="roundRect">
+            <a:avLst/>
+          </a:prstGeom>
+          <a:solidFill>
+            <a:srgbClr val="0F766E"/>
+          </a:solidFill>
+          <a:ln w="9525">
+            <a:solidFill>
+              <a:srgbClr val="0F766E"/>
+            </a:solidFill>
+          </a:ln>
+        </p:spPr>
+        <p:style>
+          <a:lnRef idx="1">
+            <a:schemeClr val="accent1"/>
+          </a:lnRef>
+          <a:fillRef idx="3">
+            <a:schemeClr val="accent1"/>
+          </a:fillRef>
+          <a:effectRef idx="2">
+            <a:schemeClr val="accent1"/>
+          </a:effectRef>
+          <a:fontRef idx="minor">
+            <a:schemeClr val="lt1"/>
+          </a:fontRef>
+        </p:style>
+        <p:txBody>
+          <a:bodyPr rtlCol="0" anchor="ctr"/>
+          <a:lstStyle/>
+          <a:p>
+            <a:pPr algn="ctr"/>
+          </a:p>
+        </p:txBody>
+      </p:sp>
+      <p:sp>
+        <p:nvSpPr>
+          <p:cNvPr id="8" name="TextBox 7"/>
+          <p:cNvSpPr txBox="1"/>
+          <p:nvPr/>
+        </p:nvSpPr>
+        <p:spPr>
+          <a:xfrm>
+            <a:off x="941832" y="1714500"/>
+            <a:ext cx="813815" cy="219456"/>
+          </a:xfrm>
+          <a:prstGeom prst="rect">
+            <a:avLst/>
+          </a:prstGeom>
+          <a:noFill/>
+        </p:spPr>
+        <p:txBody>
+          <a:bodyPr wrap="square" lIns="73152" rIns="73152" tIns="36576" bIns="36576" anchor="t">
+            <a:spAutoFit/>
+          </a:bodyPr>
+          <a:lstStyle/>
+          <a:p>
+            <a:pPr algn="ctr">
+              <a:defRPr sz="1000" b="1">
+                <a:solidFill>
+                  <a:srgbClr val="FFFFFF"/>
+                </a:solidFill>
+                <a:latin typeface="Malgun Gothic"/>
+              </a:defRPr>
+            </a:pPr>
+            <a:r>
+              <a:t>적응</a:t>
+            </a:r>
+          </a:p>
+        </p:txBody>
+      </p:sp>
+      <p:sp>
+        <p:nvSpPr>
+          <p:cNvPr id="9" name="TextBox 8"/>
+          <p:cNvSpPr txBox="1"/>
+          <p:nvPr/>
+        </p:nvSpPr>
+        <p:spPr>
+          <a:xfrm>
+            <a:off x="914400" y="2130552"/>
+            <a:ext cx="2788920" cy="530352"/>
+          </a:xfrm>
+          <a:prstGeom prst="rect">
+            <a:avLst/>
+          </a:prstGeom>
+          <a:noFill/>
+        </p:spPr>
+        <p:txBody>
+          <a:bodyPr wrap="square" lIns="73152" rIns="73152" tIns="36576" bIns="36576" anchor="t">
+            <a:spAutoFit/>
+          </a:bodyPr>
+          <a:lstStyle/>
+          <a:p>
+            <a:pPr algn="l">
+              <a:defRPr sz="1400" b="1">
+                <a:solidFill>
+                  <a:srgbClr val="1F2937"/>
+                </a:solidFill>
+                <a:latin typeface="Malgun Gothic"/>
+              </a:defRPr>
+            </a:pPr>
+            <a:r>
+              <a:t>생애주기 탄소중립 교육 및 시민의식 개선</a:t>
+            </a:r>
+          </a:p>
+        </p:txBody>
+      </p:sp>
+      <p:sp>
+        <p:nvSpPr>
+          <p:cNvPr id="10" name="TextBox 9"/>
+          <p:cNvSpPr txBox="1"/>
+          <p:nvPr/>
+        </p:nvSpPr>
+        <p:spPr>
+          <a:xfrm>
+            <a:off x="914400" y="2816352"/>
+            <a:ext cx="2834640" cy="292608"/>
+          </a:xfrm>
+          <a:prstGeom prst="rect">
+            <a:avLst/>
+          </a:prstGeom>
+          <a:noFill/>
+        </p:spPr>
+        <p:txBody>
+          <a:bodyPr wrap="square" lIns="73152" rIns="73152" tIns="36576" bIns="36576" anchor="t">
+            <a:spAutoFit/>
+          </a:bodyPr>
+          <a:lstStyle/>
+          <a:p>
+            <a:pPr algn="l">
+              <a:defRPr sz="900" b="1">
+                <a:solidFill>
+                  <a:srgbClr val="0F766E"/>
+                </a:solidFill>
+                <a:latin typeface="Malgun Gothic"/>
+              </a:defRPr>
+            </a:pPr>
+            <a:r>
+              <a:t>v6 시나리오상 통합 설명</a:t>
+            </a:r>
+          </a:p>
+        </p:txBody>
+      </p:sp>
+      <p:sp>
+        <p:nvSpPr>
+          <p:cNvPr id="11" name="TextBox 10"/>
+          <p:cNvSpPr txBox="1"/>
+          <p:nvPr/>
+        </p:nvSpPr>
+        <p:spPr>
+          <a:xfrm>
+            <a:off x="914400" y="3310128"/>
+            <a:ext cx="2834640" cy="658368"/>
+          </a:xfrm>
+          <a:prstGeom prst="rect">
+            <a:avLst/>
+          </a:prstGeom>
+          <a:noFill/>
+        </p:spPr>
+        <p:txBody>
+          <a:bodyPr wrap="square" lIns="73152" rIns="73152" tIns="36576" bIns="36576" anchor="t">
+            <a:spAutoFit/>
+          </a:bodyPr>
+          <a:lstStyle/>
+          <a:p>
+            <a:pPr algn="l">
+              <a:defRPr sz="800" b="0">
+                <a:solidFill>
+                  <a:srgbClr val="64748B"/>
+                </a:solidFill>
+                <a:latin typeface="Malgun Gothic"/>
+              </a:defRPr>
+            </a:pPr>
+            <a:r>
+              <a:t>- 사전 접수와 조별 숙의에서 교육·시민참여 맥락이 반복됨</a:t>
+            </a:r>
+          </a:p>
+          <a:p>
+            <a:pPr algn="l">
+              <a:defRPr sz="800" b="0">
+                <a:solidFill>
+                  <a:srgbClr val="64748B"/>
+                </a:solidFill>
+                <a:latin typeface="Malgun Gothic"/>
+              </a:defRPr>
+            </a:pPr>
+            <a:r>
+              <a:t>- 교육 의제가 평가 1위, 시민참여 의제가 공동 2위로 확인됨</a:t>
+            </a:r>
+          </a:p>
+        </p:txBody>
+      </p:sp>
+      <p:sp>
+        <p:nvSpPr>
+          <p:cNvPr id="12" name="Rounded Rectangle 11"/>
+          <p:cNvSpPr/>
+          <p:nvPr/>
+        </p:nvSpPr>
+        <p:spPr>
+          <a:xfrm>
+            <a:off x="4480560" y="1417320"/>
+            <a:ext cx="3337560" cy="3246120"/>
+          </a:xfrm>
+          <a:prstGeom prst="roundRect">
+            <a:avLst/>
+          </a:prstGeom>
+          <a:solidFill>
+            <a:srgbClr val="FFFFFF"/>
+          </a:solidFill>
+          <a:ln w="9525">
+            <a:solidFill>
+              <a:srgbClr val="0891B2"/>
+            </a:solidFill>
+          </a:ln>
+        </p:spPr>
+        <p:style>
+          <a:lnRef idx="1">
+            <a:schemeClr val="accent1"/>
+          </a:lnRef>
+          <a:fillRef idx="3">
+            <a:schemeClr val="accent1"/>
+          </a:fillRef>
+          <a:effectRef idx="2">
+            <a:schemeClr val="accent1"/>
+          </a:effectRef>
+          <a:fontRef idx="minor">
+            <a:schemeClr val="lt1"/>
+          </a:fontRef>
+        </p:style>
+        <p:txBody>
+          <a:bodyPr rtlCol="0" anchor="ctr"/>
+          <a:lstStyle/>
+          <a:p>
+            <a:pPr algn="ctr"/>
+          </a:p>
+        </p:txBody>
+      </p:sp>
+      <p:sp>
+        <p:nvSpPr>
+          <p:cNvPr id="13" name="Rounded Rectangle 12"/>
+          <p:cNvSpPr/>
+          <p:nvPr/>
+        </p:nvSpPr>
+        <p:spPr>
+          <a:xfrm>
+            <a:off x="4709160" y="1664208"/>
+            <a:ext cx="868680" cy="329184"/>
+          </a:xfrm>
+          <a:prstGeom prst="roundRect">
+            <a:avLst/>
+          </a:prstGeom>
+          <a:solidFill>
+            <a:srgbClr val="0891B2"/>
+          </a:solidFill>
+          <a:ln w="9525">
+            <a:solidFill>
+              <a:srgbClr val="0891B2"/>
+            </a:solidFill>
+          </a:ln>
+        </p:spPr>
+        <p:style>
+          <a:lnRef idx="1">
+            <a:schemeClr val="accent1"/>
+          </a:lnRef>
+          <a:fillRef idx="3">
+            <a:schemeClr val="accent1"/>
+          </a:fillRef>
+          <a:effectRef idx="2">
+            <a:schemeClr val="accent1"/>
+          </a:effectRef>
+          <a:fontRef idx="minor">
+            <a:schemeClr val="lt1"/>
+          </a:fontRef>
+        </p:style>
+        <p:txBody>
+          <a:bodyPr rtlCol="0" anchor="ctr"/>
+          <a:lstStyle/>
+          <a:p>
+            <a:pPr algn="ctr"/>
+          </a:p>
+        </p:txBody>
+      </p:sp>
+      <p:sp>
+        <p:nvSpPr>
+          <p:cNvPr id="14" name="TextBox 13"/>
+          <p:cNvSpPr txBox="1"/>
+          <p:nvPr/>
+        </p:nvSpPr>
+        <p:spPr>
+          <a:xfrm>
+            <a:off x="4736592" y="1714500"/>
+            <a:ext cx="813815" cy="219456"/>
+          </a:xfrm>
+          <a:prstGeom prst="rect">
+            <a:avLst/>
+          </a:prstGeom>
+          <a:noFill/>
+        </p:spPr>
+        <p:txBody>
+          <a:bodyPr wrap="square" lIns="73152" rIns="73152" tIns="36576" bIns="36576" anchor="t">
+            <a:spAutoFit/>
+          </a:bodyPr>
+          <a:lstStyle/>
+          <a:p>
+            <a:pPr algn="ctr">
+              <a:defRPr sz="1000" b="1">
+                <a:solidFill>
+                  <a:srgbClr val="FFFFFF"/>
+                </a:solidFill>
+                <a:latin typeface="Malgun Gothic"/>
+              </a:defRPr>
+            </a:pPr>
+            <a:r>
+              <a:t>감축1</a:t>
+            </a:r>
+          </a:p>
+        </p:txBody>
+      </p:sp>
+      <p:sp>
+        <p:nvSpPr>
+          <p:cNvPr id="15" name="TextBox 14"/>
+          <p:cNvSpPr txBox="1"/>
+          <p:nvPr/>
+        </p:nvSpPr>
+        <p:spPr>
+          <a:xfrm>
+            <a:off x="4709160" y="2130552"/>
+            <a:ext cx="2788920" cy="530352"/>
+          </a:xfrm>
+          <a:prstGeom prst="rect">
+            <a:avLst/>
+          </a:prstGeom>
+          <a:noFill/>
+        </p:spPr>
+        <p:txBody>
+          <a:bodyPr wrap="square" lIns="73152" rIns="73152" tIns="36576" bIns="36576" anchor="t">
+            <a:spAutoFit/>
+          </a:bodyPr>
+          <a:lstStyle/>
+          <a:p>
+            <a:pPr algn="l">
+              <a:defRPr sz="1400" b="1">
+                <a:solidFill>
+                  <a:srgbClr val="1F2937"/>
+                </a:solidFill>
+                <a:latin typeface="Malgun Gothic"/>
+              </a:defRPr>
+            </a:pPr>
+            <a:r>
+              <a:t>자원순환·생활폐기물 감축</a:t>
+            </a:r>
+          </a:p>
+        </p:txBody>
+      </p:sp>
+      <p:sp>
+        <p:nvSpPr>
+          <p:cNvPr id="16" name="TextBox 15"/>
+          <p:cNvSpPr txBox="1"/>
+          <p:nvPr/>
+        </p:nvSpPr>
+        <p:spPr>
+          <a:xfrm>
+            <a:off x="4709160" y="2816352"/>
+            <a:ext cx="2834640" cy="292608"/>
+          </a:xfrm>
+          <a:prstGeom prst="rect">
+            <a:avLst/>
+          </a:prstGeom>
+          <a:noFill/>
+        </p:spPr>
+        <p:txBody>
+          <a:bodyPr wrap="square" lIns="73152" rIns="73152" tIns="36576" bIns="36576" anchor="t">
+            <a:spAutoFit/>
+          </a:bodyPr>
+          <a:lstStyle/>
+          <a:p>
+            <a:pPr algn="l">
+              <a:defRPr sz="900" b="1">
+                <a:solidFill>
+                  <a:srgbClr val="0891B2"/>
+                </a:solidFill>
+                <a:latin typeface="Malgun Gothic"/>
+              </a:defRPr>
+            </a:pPr>
+            <a:r>
+              <a:t>v6 시나리오상 확정 설명 가능</a:t>
+            </a:r>
+          </a:p>
+        </p:txBody>
+      </p:sp>
+      <p:sp>
+        <p:nvSpPr>
+          <p:cNvPr id="17" name="TextBox 16"/>
+          <p:cNvSpPr txBox="1"/>
+          <p:nvPr/>
+        </p:nvSpPr>
+        <p:spPr>
+          <a:xfrm>
+            <a:off x="4709160" y="3310128"/>
+            <a:ext cx="2834640" cy="658368"/>
+          </a:xfrm>
+          <a:prstGeom prst="rect">
+            <a:avLst/>
+          </a:prstGeom>
+          <a:noFill/>
+        </p:spPr>
+        <p:txBody>
+          <a:bodyPr wrap="square" lIns="73152" rIns="73152" tIns="36576" bIns="36576" anchor="t">
+            <a:spAutoFit/>
+          </a:bodyPr>
+          <a:lstStyle/>
+          <a:p>
+            <a:pPr algn="l">
+              <a:defRPr sz="800" b="0">
+                <a:solidFill>
+                  <a:srgbClr val="64748B"/>
+                </a:solidFill>
+                <a:latin typeface="Malgun Gothic"/>
+              </a:defRPr>
+            </a:pPr>
+            <a:r>
+              <a:t>- 사전 접수 분석에서 소비·생활양식과 자원순환 흐름이 크게 나타남</a:t>
+            </a:r>
+          </a:p>
+          <a:p>
+            <a:pPr algn="l">
+              <a:defRPr sz="800" b="0">
+                <a:solidFill>
+                  <a:srgbClr val="64748B"/>
+                </a:solidFill>
+                <a:latin typeface="Malgun Gothic"/>
+              </a:defRPr>
+            </a:pPr>
+            <a:r>
+              <a:t>- A조 자원순환형 배달 문화와 B조 생활폐기물 감축 논의를 통합함</a:t>
+            </a:r>
+          </a:p>
+        </p:txBody>
+      </p:sp>
+      <p:sp>
+        <p:nvSpPr>
+          <p:cNvPr id="18" name="Rounded Rectangle 17"/>
+          <p:cNvSpPr/>
+          <p:nvPr/>
+        </p:nvSpPr>
+        <p:spPr>
+          <a:xfrm>
+            <a:off x="8275320" y="1417320"/>
+            <a:ext cx="3337560" cy="3246120"/>
           </a:xfrm>
           <a:prstGeom prst="roundRect">
             <a:avLst/>
@@ -13176,14 +13957,14 @@
       </p:sp>
       <p:sp>
         <p:nvSpPr>
-          <p:cNvPr id="7" name="Rounded Rectangle 6"/>
+          <p:cNvPr id="19" name="Rounded Rectangle 18"/>
           <p:cNvSpPr/>
           <p:nvPr/>
         </p:nvSpPr>
         <p:spPr>
           <a:xfrm>
-            <a:off x="1051560" y="1728216"/>
-            <a:ext cx="1143000" cy="329184"/>
+            <a:off x="8503920" y="1664208"/>
+            <a:ext cx="868680" cy="329184"/>
           </a:xfrm>
           <a:prstGeom prst="roundRect">
             <a:avLst/>
@@ -13221,14 +14002,14 @@
       </p:sp>
       <p:sp>
         <p:nvSpPr>
-          <p:cNvPr id="8" name="TextBox 7"/>
-          <p:cNvSpPr txBox="1"/>
-          <p:nvPr/>
-        </p:nvSpPr>
-        <p:spPr>
-          <a:xfrm>
-            <a:off x="1078992" y="1778507"/>
-            <a:ext cx="1088136" cy="219456"/>
+          <p:cNvPr id="20" name="TextBox 19"/>
+          <p:cNvSpPr txBox="1"/>
+          <p:nvPr/>
+        </p:nvSpPr>
+        <p:spPr>
+          <a:xfrm>
+            <a:off x="8531352" y="1714500"/>
+            <a:ext cx="813815" cy="219456"/>
           </a:xfrm>
           <a:prstGeom prst="rect">
             <a:avLst/>
@@ -13250,21 +14031,21 @@
               </a:defRPr>
             </a:pPr>
             <a:r>
-              <a:t>B_t2</a:t>
-            </a:r>
-          </a:p>
-        </p:txBody>
-      </p:sp>
-      <p:sp>
-        <p:nvSpPr>
-          <p:cNvPr id="9" name="TextBox 8"/>
-          <p:cNvSpPr txBox="1"/>
-          <p:nvPr/>
-        </p:nvSpPr>
-        <p:spPr>
-          <a:xfrm>
-            <a:off x="2395728" y="1673351"/>
-            <a:ext cx="2560320" cy="237744"/>
+              <a:t>감축2</a:t>
+            </a:r>
+          </a:p>
+        </p:txBody>
+      </p:sp>
+      <p:sp>
+        <p:nvSpPr>
+          <p:cNvPr id="21" name="TextBox 20"/>
+          <p:cNvSpPr txBox="1"/>
+          <p:nvPr/>
+        </p:nvSpPr>
+        <p:spPr>
+          <a:xfrm>
+            <a:off x="8503920" y="2130552"/>
+            <a:ext cx="2788920" cy="530352"/>
           </a:xfrm>
           <a:prstGeom prst="rect">
             <a:avLst/>
@@ -13278,7 +14059,7 @@
           <a:lstStyle/>
           <a:p>
             <a:pPr algn="l">
-              <a:defRPr sz="1300" b="1">
+              <a:defRPr sz="1400" b="1">
                 <a:solidFill>
                   <a:srgbClr val="1F2937"/>
                 </a:solidFill>
@@ -13286,21 +14067,21 @@
               </a:defRPr>
             </a:pPr>
             <a:r>
-              <a:t>6/14 B조 토론2</a:t>
-            </a:r>
-          </a:p>
-        </p:txBody>
-      </p:sp>
-      <p:sp>
-        <p:nvSpPr>
-          <p:cNvPr id="10" name="TextBox 9"/>
-          <p:cNvSpPr txBox="1"/>
-          <p:nvPr/>
-        </p:nvSpPr>
-        <p:spPr>
-          <a:xfrm>
-            <a:off x="5166360" y="1700784"/>
-            <a:ext cx="5349240" cy="219456"/>
+              <a:t>새로운 의제 슬롯</a:t>
+            </a:r>
+          </a:p>
+        </p:txBody>
+      </p:sp>
+      <p:sp>
+        <p:nvSpPr>
+          <p:cNvPr id="22" name="TextBox 21"/>
+          <p:cNvSpPr txBox="1"/>
+          <p:nvPr/>
+        </p:nvSpPr>
+        <p:spPr>
+          <a:xfrm>
+            <a:off x="8503920" y="2816352"/>
+            <a:ext cx="2834640" cy="292608"/>
           </a:xfrm>
           <a:prstGeom prst="rect">
             <a:avLst/>
@@ -13314,7 +14095,43 @@
           <a:lstStyle/>
           <a:p>
             <a:pPr algn="l">
-              <a:defRPr sz="1000" b="0">
+              <a:defRPr sz="900" b="1">
+                <a:solidFill>
+                  <a:srgbClr val="BE123C"/>
+                </a:solidFill>
+                <a:latin typeface="Malgun Gothic"/>
+              </a:defRPr>
+            </a:pPr>
+            <a:r>
+              <a:t>v6 시나리오상 확정명 증거 부족</a:t>
+            </a:r>
+          </a:p>
+        </p:txBody>
+      </p:sp>
+      <p:sp>
+        <p:nvSpPr>
+          <p:cNvPr id="23" name="TextBox 22"/>
+          <p:cNvSpPr txBox="1"/>
+          <p:nvPr/>
+        </p:nvSpPr>
+        <p:spPr>
+          <a:xfrm>
+            <a:off x="8503920" y="3310128"/>
+            <a:ext cx="2834640" cy="658368"/>
+          </a:xfrm>
+          <a:prstGeom prst="rect">
+            <a:avLst/>
+          </a:prstGeom>
+          <a:noFill/>
+        </p:spPr>
+        <p:txBody>
+          <a:bodyPr wrap="square" lIns="73152" rIns="73152" tIns="36576" bIns="36576" anchor="t">
+            <a:spAutoFit/>
+          </a:bodyPr>
+          <a:lstStyle/>
+          <a:p>
+            <a:pPr algn="l">
+              <a:defRPr sz="800" b="0">
                 <a:solidFill>
                   <a:srgbClr val="64748B"/>
                 </a:solidFill>
@@ -13322,111 +14139,34 @@
               </a:defRPr>
             </a:pPr>
             <a:r>
-              <a:t>상태: needs_review / 전사: transcript_partial / 그래프: graph_represented / 노드: 20</a:t>
-            </a:r>
-          </a:p>
-        </p:txBody>
-      </p:sp>
-      <p:sp>
-        <p:nvSpPr>
-          <p:cNvPr id="11" name="Rounded Rectangle 10"/>
-          <p:cNvSpPr/>
-          <p:nvPr/>
-        </p:nvSpPr>
-        <p:spPr>
-          <a:xfrm>
-            <a:off x="822960" y="2651760"/>
-            <a:ext cx="10424160" cy="841248"/>
-          </a:xfrm>
-          <a:prstGeom prst="roundRect">
-            <a:avLst/>
-          </a:prstGeom>
-          <a:solidFill>
-            <a:srgbClr val="FFFFFF"/>
-          </a:solidFill>
-          <a:ln w="9525">
-            <a:solidFill>
-              <a:srgbClr val="BE123C"/>
-            </a:solidFill>
-          </a:ln>
-        </p:spPr>
-        <p:style>
-          <a:lnRef idx="1">
-            <a:schemeClr val="accent1"/>
-          </a:lnRef>
-          <a:fillRef idx="3">
-            <a:schemeClr val="accent1"/>
-          </a:fillRef>
-          <a:effectRef idx="2">
-            <a:schemeClr val="accent1"/>
-          </a:effectRef>
-          <a:fontRef idx="minor">
-            <a:schemeClr val="lt1"/>
-          </a:fontRef>
-        </p:style>
-        <p:txBody>
-          <a:bodyPr rtlCol="0" anchor="ctr"/>
-          <a:lstStyle/>
-          <a:p>
-            <a:pPr algn="ctr"/>
-          </a:p>
-        </p:txBody>
-      </p:sp>
-      <p:sp>
-        <p:nvSpPr>
-          <p:cNvPr id="12" name="Rounded Rectangle 11"/>
-          <p:cNvSpPr/>
-          <p:nvPr/>
-        </p:nvSpPr>
-        <p:spPr>
-          <a:xfrm>
-            <a:off x="1051560" y="2871215"/>
-            <a:ext cx="1143000" cy="329184"/>
-          </a:xfrm>
-          <a:prstGeom prst="roundRect">
-            <a:avLst/>
-          </a:prstGeom>
-          <a:solidFill>
-            <a:srgbClr val="BE123C"/>
-          </a:solidFill>
-          <a:ln w="9525">
-            <a:solidFill>
-              <a:srgbClr val="BE123C"/>
-            </a:solidFill>
-          </a:ln>
-        </p:spPr>
-        <p:style>
-          <a:lnRef idx="1">
-            <a:schemeClr val="accent1"/>
-          </a:lnRef>
-          <a:fillRef idx="3">
-            <a:schemeClr val="accent1"/>
-          </a:fillRef>
-          <a:effectRef idx="2">
-            <a:schemeClr val="accent1"/>
-          </a:effectRef>
-          <a:fontRef idx="minor">
-            <a:schemeClr val="lt1"/>
-          </a:fontRef>
-        </p:style>
-        <p:txBody>
-          <a:bodyPr rtlCol="0" anchor="ctr"/>
-          <a:lstStyle/>
-          <a:p>
-            <a:pPr algn="ctr"/>
-          </a:p>
-        </p:txBody>
-      </p:sp>
-      <p:sp>
-        <p:nvSpPr>
-          <p:cNvPr id="13" name="TextBox 12"/>
-          <p:cNvSpPr txBox="1"/>
-          <p:nvPr/>
-        </p:nvSpPr>
-        <p:spPr>
-          <a:xfrm>
-            <a:off x="1078992" y="2921508"/>
-            <a:ext cx="1088136" cy="219456"/>
+              <a:t>- 시민의식 개선 후보가 교육 의제에 통합되며 세 번째 자리가 열림</a:t>
+            </a:r>
+          </a:p>
+          <a:p>
+            <a:pPr algn="l">
+              <a:defRPr sz="800" b="0">
+                <a:solidFill>
+                  <a:srgbClr val="64748B"/>
+                </a:solidFill>
+                <a:latin typeface="Malgun Gothic"/>
+              </a:defRPr>
+            </a:pPr>
+            <a:r>
+              <a:t>- 발표 시나리오 7쪽·10쪽에 7.4 당일 확정 후 수정 표시가 남아 있음</a:t>
+            </a:r>
+          </a:p>
+        </p:txBody>
+      </p:sp>
+      <p:sp>
+        <p:nvSpPr>
+          <p:cNvPr id="24" name="TextBox 23"/>
+          <p:cNvSpPr txBox="1"/>
+          <p:nvPr/>
+        </p:nvSpPr>
+        <p:spPr>
+          <a:xfrm>
+            <a:off x="960120" y="5303520"/>
+            <a:ext cx="10149840" cy="384048"/>
           </a:xfrm>
           <a:prstGeom prst="rect">
             <a:avLst/>
@@ -13440,313 +14180,7 @@
           <a:lstStyle/>
           <a:p>
             <a:pPr algn="ctr">
-              <a:defRPr sz="1000" b="1">
-                <a:solidFill>
-                  <a:srgbClr val="FFFFFF"/>
-                </a:solidFill>
-                <a:latin typeface="Malgun Gothic"/>
-              </a:defRPr>
-            </a:pPr>
-            <a:r>
-              <a:t>토론4통합</a:t>
-            </a:r>
-          </a:p>
-        </p:txBody>
-      </p:sp>
-      <p:sp>
-        <p:nvSpPr>
-          <p:cNvPr id="14" name="TextBox 13"/>
-          <p:cNvSpPr txBox="1"/>
-          <p:nvPr/>
-        </p:nvSpPr>
-        <p:spPr>
-          <a:xfrm>
-            <a:off x="2395728" y="2816352"/>
-            <a:ext cx="2560320" cy="237744"/>
-          </a:xfrm>
-          <a:prstGeom prst="rect">
-            <a:avLst/>
-          </a:prstGeom>
-          <a:noFill/>
-        </p:spPr>
-        <p:txBody>
-          <a:bodyPr wrap="square" lIns="73152" rIns="73152" tIns="36576" bIns="36576" anchor="t">
-            <a:spAutoFit/>
-          </a:bodyPr>
-          <a:lstStyle/>
-          <a:p>
-            <a:pPr algn="l">
-              <a:defRPr sz="1300" b="1">
-                <a:solidFill>
-                  <a:srgbClr val="1F2937"/>
-                </a:solidFill>
-                <a:latin typeface="Malgun Gothic"/>
-              </a:defRPr>
-            </a:pPr>
-            <a:r>
-              <a:t>6/14 토론4 통합 운영</a:t>
-            </a:r>
-          </a:p>
-        </p:txBody>
-      </p:sp>
-      <p:sp>
-        <p:nvSpPr>
-          <p:cNvPr id="15" name="TextBox 14"/>
-          <p:cNvSpPr txBox="1"/>
-          <p:nvPr/>
-        </p:nvSpPr>
-        <p:spPr>
-          <a:xfrm>
-            <a:off x="5166360" y="2843784"/>
-            <a:ext cx="5349240" cy="219456"/>
-          </a:xfrm>
-          <a:prstGeom prst="rect">
-            <a:avLst/>
-          </a:prstGeom>
-          <a:noFill/>
-        </p:spPr>
-        <p:txBody>
-          <a:bodyPr wrap="square" lIns="73152" rIns="73152" tIns="36576" bIns="36576" anchor="t">
-            <a:spAutoFit/>
-          </a:bodyPr>
-          <a:lstStyle/>
-          <a:p>
-            <a:pPr algn="l">
-              <a:defRPr sz="1000" b="0">
-                <a:solidFill>
-                  <a:srgbClr val="64748B"/>
-                </a:solidFill>
-                <a:latin typeface="Malgun Gothic"/>
-              </a:defRPr>
-            </a:pPr>
-            <a:r>
-              <a:t>상태: needs_review / 전사: transcript_partial / 그래프: not_expected_in_current_graph / 노드: 0</a:t>
-            </a:r>
-          </a:p>
-        </p:txBody>
-      </p:sp>
-      <p:sp>
-        <p:nvSpPr>
-          <p:cNvPr id="16" name="Rounded Rectangle 15"/>
-          <p:cNvSpPr/>
-          <p:nvPr/>
-        </p:nvSpPr>
-        <p:spPr>
-          <a:xfrm>
-            <a:off x="822960" y="3794760"/>
-            <a:ext cx="10424160" cy="841248"/>
-          </a:xfrm>
-          <a:prstGeom prst="roundRect">
-            <a:avLst/>
-          </a:prstGeom>
-          <a:solidFill>
-            <a:srgbClr val="FFFFFF"/>
-          </a:solidFill>
-          <a:ln w="9525">
-            <a:solidFill>
-              <a:srgbClr val="BE123C"/>
-            </a:solidFill>
-          </a:ln>
-        </p:spPr>
-        <p:style>
-          <a:lnRef idx="1">
-            <a:schemeClr val="accent1"/>
-          </a:lnRef>
-          <a:fillRef idx="3">
-            <a:schemeClr val="accent1"/>
-          </a:fillRef>
-          <a:effectRef idx="2">
-            <a:schemeClr val="accent1"/>
-          </a:effectRef>
-          <a:fontRef idx="minor">
-            <a:schemeClr val="lt1"/>
-          </a:fontRef>
-        </p:style>
-        <p:txBody>
-          <a:bodyPr rtlCol="0" anchor="ctr"/>
-          <a:lstStyle/>
-          <a:p>
-            <a:pPr algn="ctr"/>
-          </a:p>
-        </p:txBody>
-      </p:sp>
-      <p:sp>
-        <p:nvSpPr>
-          <p:cNvPr id="17" name="Rounded Rectangle 16"/>
-          <p:cNvSpPr/>
-          <p:nvPr/>
-        </p:nvSpPr>
-        <p:spPr>
-          <a:xfrm>
-            <a:off x="1051560" y="4014216"/>
-            <a:ext cx="1143000" cy="329184"/>
-          </a:xfrm>
-          <a:prstGeom prst="roundRect">
-            <a:avLst/>
-          </a:prstGeom>
-          <a:solidFill>
-            <a:srgbClr val="BE123C"/>
-          </a:solidFill>
-          <a:ln w="9525">
-            <a:solidFill>
-              <a:srgbClr val="BE123C"/>
-            </a:solidFill>
-          </a:ln>
-        </p:spPr>
-        <p:style>
-          <a:lnRef idx="1">
-            <a:schemeClr val="accent1"/>
-          </a:lnRef>
-          <a:fillRef idx="3">
-            <a:schemeClr val="accent1"/>
-          </a:fillRef>
-          <a:effectRef idx="2">
-            <a:schemeClr val="accent1"/>
-          </a:effectRef>
-          <a:fontRef idx="minor">
-            <a:schemeClr val="lt1"/>
-          </a:fontRef>
-        </p:style>
-        <p:txBody>
-          <a:bodyPr rtlCol="0" anchor="ctr"/>
-          <a:lstStyle/>
-          <a:p>
-            <a:pPr algn="ctr"/>
-          </a:p>
-        </p:txBody>
-      </p:sp>
-      <p:sp>
-        <p:nvSpPr>
-          <p:cNvPr id="18" name="TextBox 17"/>
-          <p:cNvSpPr txBox="1"/>
-          <p:nvPr/>
-        </p:nvSpPr>
-        <p:spPr>
-          <a:xfrm>
-            <a:off x="1078992" y="4064508"/>
-            <a:ext cx="1088136" cy="219456"/>
-          </a:xfrm>
-          <a:prstGeom prst="rect">
-            <a:avLst/>
-          </a:prstGeom>
-          <a:noFill/>
-        </p:spPr>
-        <p:txBody>
-          <a:bodyPr wrap="square" lIns="73152" rIns="73152" tIns="36576" bIns="36576" anchor="t">
-            <a:spAutoFit/>
-          </a:bodyPr>
-          <a:lstStyle/>
-          <a:p>
-            <a:pPr algn="ctr">
-              <a:defRPr sz="1000" b="1">
-                <a:solidFill>
-                  <a:srgbClr val="FFFFFF"/>
-                </a:solidFill>
-                <a:latin typeface="Malgun Gothic"/>
-              </a:defRPr>
-            </a:pPr>
-            <a:r>
-              <a:t>음성002</a:t>
-            </a:r>
-          </a:p>
-        </p:txBody>
-      </p:sp>
-      <p:sp>
-        <p:nvSpPr>
-          <p:cNvPr id="19" name="TextBox 18"/>
-          <p:cNvSpPr txBox="1"/>
-          <p:nvPr/>
-        </p:nvSpPr>
-        <p:spPr>
-          <a:xfrm>
-            <a:off x="2395728" y="3959352"/>
-            <a:ext cx="2560320" cy="237744"/>
-          </a:xfrm>
-          <a:prstGeom prst="rect">
-            <a:avLst/>
-          </a:prstGeom>
-          <a:noFill/>
-        </p:spPr>
-        <p:txBody>
-          <a:bodyPr wrap="square" lIns="73152" rIns="73152" tIns="36576" bIns="36576" anchor="t">
-            <a:spAutoFit/>
-          </a:bodyPr>
-          <a:lstStyle/>
-          <a:p>
-            <a:pPr algn="l">
-              <a:defRPr sz="1300" b="1">
-                <a:solidFill>
-                  <a:srgbClr val="1F2937"/>
-                </a:solidFill>
-                <a:latin typeface="Malgun Gothic"/>
-              </a:defRPr>
-            </a:pPr>
-            <a:r>
-              <a:t>음성 002</a:t>
-            </a:r>
-          </a:p>
-        </p:txBody>
-      </p:sp>
-      <p:sp>
-        <p:nvSpPr>
-          <p:cNvPr id="20" name="TextBox 19"/>
-          <p:cNvSpPr txBox="1"/>
-          <p:nvPr/>
-        </p:nvSpPr>
-        <p:spPr>
-          <a:xfrm>
-            <a:off x="5166360" y="3986784"/>
-            <a:ext cx="5349240" cy="219456"/>
-          </a:xfrm>
-          <a:prstGeom prst="rect">
-            <a:avLst/>
-          </a:prstGeom>
-          <a:noFill/>
-        </p:spPr>
-        <p:txBody>
-          <a:bodyPr wrap="square" lIns="73152" rIns="73152" tIns="36576" bIns="36576" anchor="t">
-            <a:spAutoFit/>
-          </a:bodyPr>
-          <a:lstStyle/>
-          <a:p>
-            <a:pPr algn="l">
-              <a:defRPr sz="1000" b="0">
-                <a:solidFill>
-                  <a:srgbClr val="64748B"/>
-                </a:solidFill>
-                <a:latin typeface="Malgun Gothic"/>
-              </a:defRPr>
-            </a:pPr>
-            <a:r>
-              <a:t>상태: ui_or_graph_gap / 전사: transcript_ready / 그래프: not_expected_in_current_graph / 노드: 0</a:t>
-            </a:r>
-          </a:p>
-        </p:txBody>
-      </p:sp>
-      <p:sp>
-        <p:nvSpPr>
-          <p:cNvPr id="21" name="TextBox 20"/>
-          <p:cNvSpPr txBox="1"/>
-          <p:nvPr/>
-        </p:nvSpPr>
-        <p:spPr>
-          <a:xfrm>
-            <a:off x="960120" y="5303520"/>
-            <a:ext cx="10058400" cy="384048"/>
-          </a:xfrm>
-          <a:prstGeom prst="rect">
-            <a:avLst/>
-          </a:prstGeom>
-          <a:noFill/>
-        </p:spPr>
-        <p:txBody>
-          <a:bodyPr wrap="square" lIns="73152" rIns="73152" tIns="36576" bIns="36576" anchor="t">
-            <a:spAutoFit/>
-          </a:bodyPr>
-          <a:lstStyle/>
-          <a:p>
-            <a:pPr algn="ctr">
-              <a:defRPr sz="1700" b="1">
+              <a:defRPr sz="1500" b="1">
                 <a:solidFill>
                   <a:srgbClr val="BE123C"/>
                 </a:solidFill>
@@ -13754,7 +14188,7 @@
               </a:defRPr>
             </a:pPr>
             <a:r>
-              <a:t>이 3건이 남아 있기 때문에 `모든 입력이 완전 반영`이라는 표현은 아직 금물이다.</a:t>
+              <a:t>따라서 발표에서는 `현재 숙의의제 덱 기준 3의제`와 `v6 시나리오의 통합/미확정 슬롯`을 섞어 말하지 않는다.</a:t>
             </a:r>
           </a:p>
         </p:txBody>
@@ -13816,7 +14250,7 @@
               </a:defRPr>
             </a:pPr>
             <a:r>
-              <a:t>8. 발표용 한 문장</a:t>
+              <a:t>8. 남은 검증 게이트</a:t>
             </a:r>
           </a:p>
         </p:txBody>
@@ -13852,7 +14286,7 @@
               </a:defRPr>
             </a:pPr>
             <a:r>
-              <a:t>운영규정과 의제 결과를 같이 묶는 닫는 말</a:t>
+              <a:t>완전 반영 완료라고 말하기 전에 닫아야 할 항목</a:t>
             </a:r>
           </a:p>
         </p:txBody>
@@ -13936,8 +14370,8 @@
         </p:nvSpPr>
         <p:spPr>
           <a:xfrm>
-            <a:off x="1051560" y="1508760"/>
-            <a:ext cx="10058400" cy="2834640"/>
+            <a:off x="822960" y="1508760"/>
+            <a:ext cx="10424160" cy="841248"/>
           </a:xfrm>
           <a:prstGeom prst="roundRect">
             <a:avLst/>
@@ -13947,7 +14381,7 @@
           </a:solidFill>
           <a:ln w="9525">
             <a:solidFill>
-              <a:srgbClr val="0F766E"/>
+              <a:srgbClr val="BE123C"/>
             </a:solidFill>
           </a:ln>
         </p:spPr>
@@ -13975,28 +14409,109 @@
       </p:sp>
       <p:sp>
         <p:nvSpPr>
-          <p:cNvPr id="7" name="TextBox 6"/>
-          <p:cNvSpPr txBox="1"/>
-          <p:nvPr/>
-        </p:nvSpPr>
-        <p:spPr>
-          <a:xfrm>
-            <a:off x="1600200" y="2057400"/>
-            <a:ext cx="8915400" cy="1143000"/>
-          </a:xfrm>
-          <a:prstGeom prst="rect">
-            <a:avLst/>
-          </a:prstGeom>
-          <a:noFill/>
-        </p:spPr>
-        <p:txBody>
-          <a:bodyPr wrap="square" lIns="73152" rIns="73152" tIns="36576" bIns="36576" anchor="ctr">
+          <p:cNvPr id="7" name="Rounded Rectangle 6"/>
+          <p:cNvSpPr/>
+          <p:nvPr/>
+        </p:nvSpPr>
+        <p:spPr>
+          <a:xfrm>
+            <a:off x="1051560" y="1728216"/>
+            <a:ext cx="1143000" cy="329184"/>
+          </a:xfrm>
+          <a:prstGeom prst="roundRect">
+            <a:avLst/>
+          </a:prstGeom>
+          <a:solidFill>
+            <a:srgbClr val="BE123C"/>
+          </a:solidFill>
+          <a:ln w="9525">
+            <a:solidFill>
+              <a:srgbClr val="BE123C"/>
+            </a:solidFill>
+          </a:ln>
+        </p:spPr>
+        <p:style>
+          <a:lnRef idx="1">
+            <a:schemeClr val="accent1"/>
+          </a:lnRef>
+          <a:fillRef idx="3">
+            <a:schemeClr val="accent1"/>
+          </a:fillRef>
+          <a:effectRef idx="2">
+            <a:schemeClr val="accent1"/>
+          </a:effectRef>
+          <a:fontRef idx="minor">
+            <a:schemeClr val="lt1"/>
+          </a:fontRef>
+        </p:style>
+        <p:txBody>
+          <a:bodyPr rtlCol="0" anchor="ctr"/>
+          <a:lstStyle/>
+          <a:p>
+            <a:pPr algn="ctr"/>
+          </a:p>
+        </p:txBody>
+      </p:sp>
+      <p:sp>
+        <p:nvSpPr>
+          <p:cNvPr id="8" name="TextBox 7"/>
+          <p:cNvSpPr txBox="1"/>
+          <p:nvPr/>
+        </p:nvSpPr>
+        <p:spPr>
+          <a:xfrm>
+            <a:off x="1078992" y="1778507"/>
+            <a:ext cx="1088136" cy="219456"/>
+          </a:xfrm>
+          <a:prstGeom prst="rect">
+            <a:avLst/>
+          </a:prstGeom>
+          <a:noFill/>
+        </p:spPr>
+        <p:txBody>
+          <a:bodyPr wrap="square" lIns="73152" rIns="73152" tIns="36576" bIns="36576" anchor="t">
             <a:spAutoFit/>
           </a:bodyPr>
           <a:lstStyle/>
           <a:p>
             <a:pPr algn="ctr">
-              <a:defRPr sz="2300" b="1">
+              <a:defRPr sz="1000" b="1">
+                <a:solidFill>
+                  <a:srgbClr val="FFFFFF"/>
+                </a:solidFill>
+                <a:latin typeface="Malgun Gothic"/>
+              </a:defRPr>
+            </a:pPr>
+            <a:r>
+              <a:t>B_t2</a:t>
+            </a:r>
+          </a:p>
+        </p:txBody>
+      </p:sp>
+      <p:sp>
+        <p:nvSpPr>
+          <p:cNvPr id="9" name="TextBox 8"/>
+          <p:cNvSpPr txBox="1"/>
+          <p:nvPr/>
+        </p:nvSpPr>
+        <p:spPr>
+          <a:xfrm>
+            <a:off x="2395728" y="1673351"/>
+            <a:ext cx="2560320" cy="237744"/>
+          </a:xfrm>
+          <a:prstGeom prst="rect">
+            <a:avLst/>
+          </a:prstGeom>
+          <a:noFill/>
+        </p:spPr>
+        <p:txBody>
+          <a:bodyPr wrap="square" lIns="73152" rIns="73152" tIns="36576" bIns="36576" anchor="t">
+            <a:spAutoFit/>
+          </a:bodyPr>
+          <a:lstStyle/>
+          <a:p>
+            <a:pPr algn="l">
+              <a:defRPr sz="1300" b="1">
                 <a:solidFill>
                   <a:srgbClr val="1F2937"/>
                 </a:solidFill>
@@ -14004,21 +14519,147 @@
               </a:defRPr>
             </a:pPr>
             <a:r>
-              <a:t>“이번 결과는 토론 하나로 바로 결론을 낸 것이 아닙니다. 시민 제안과 조별 숙의가 기준과 후보를 만들었고, 기획참여단 투표가 운영규정과 의제의 방향을 확인했으며, 겹치는 후보는 통합해서 오늘의 결론으로 정리했습니다.”</a:t>
-            </a:r>
-          </a:p>
-        </p:txBody>
-      </p:sp>
-      <p:sp>
-        <p:nvSpPr>
-          <p:cNvPr id="8" name="TextBox 7"/>
-          <p:cNvSpPr txBox="1"/>
-          <p:nvPr/>
-        </p:nvSpPr>
-        <p:spPr>
-          <a:xfrm>
-            <a:off x="1508760" y="4846320"/>
-            <a:ext cx="9326880" cy="384048"/>
+              <a:t>6/14 B조 토론2</a:t>
+            </a:r>
+          </a:p>
+        </p:txBody>
+      </p:sp>
+      <p:sp>
+        <p:nvSpPr>
+          <p:cNvPr id="10" name="TextBox 9"/>
+          <p:cNvSpPr txBox="1"/>
+          <p:nvPr/>
+        </p:nvSpPr>
+        <p:spPr>
+          <a:xfrm>
+            <a:off x="5166360" y="1700784"/>
+            <a:ext cx="5349240" cy="219456"/>
+          </a:xfrm>
+          <a:prstGeom prst="rect">
+            <a:avLst/>
+          </a:prstGeom>
+          <a:noFill/>
+        </p:spPr>
+        <p:txBody>
+          <a:bodyPr wrap="square" lIns="73152" rIns="73152" tIns="36576" bIns="36576" anchor="t">
+            <a:spAutoFit/>
+          </a:bodyPr>
+          <a:lstStyle/>
+          <a:p>
+            <a:pPr algn="l">
+              <a:defRPr sz="1000" b="0">
+                <a:solidFill>
+                  <a:srgbClr val="64748B"/>
+                </a:solidFill>
+                <a:latin typeface="Malgun Gothic"/>
+              </a:defRPr>
+            </a:pPr>
+            <a:r>
+              <a:t>상태: needs_review / 전사: transcript_partial / 그래프: graph_represented / 노드: 20</a:t>
+            </a:r>
+          </a:p>
+        </p:txBody>
+      </p:sp>
+      <p:sp>
+        <p:nvSpPr>
+          <p:cNvPr id="11" name="Rounded Rectangle 10"/>
+          <p:cNvSpPr/>
+          <p:nvPr/>
+        </p:nvSpPr>
+        <p:spPr>
+          <a:xfrm>
+            <a:off x="822960" y="2651760"/>
+            <a:ext cx="10424160" cy="841248"/>
+          </a:xfrm>
+          <a:prstGeom prst="roundRect">
+            <a:avLst/>
+          </a:prstGeom>
+          <a:solidFill>
+            <a:srgbClr val="FFFFFF"/>
+          </a:solidFill>
+          <a:ln w="9525">
+            <a:solidFill>
+              <a:srgbClr val="BE123C"/>
+            </a:solidFill>
+          </a:ln>
+        </p:spPr>
+        <p:style>
+          <a:lnRef idx="1">
+            <a:schemeClr val="accent1"/>
+          </a:lnRef>
+          <a:fillRef idx="3">
+            <a:schemeClr val="accent1"/>
+          </a:fillRef>
+          <a:effectRef idx="2">
+            <a:schemeClr val="accent1"/>
+          </a:effectRef>
+          <a:fontRef idx="minor">
+            <a:schemeClr val="lt1"/>
+          </a:fontRef>
+        </p:style>
+        <p:txBody>
+          <a:bodyPr rtlCol="0" anchor="ctr"/>
+          <a:lstStyle/>
+          <a:p>
+            <a:pPr algn="ctr"/>
+          </a:p>
+        </p:txBody>
+      </p:sp>
+      <p:sp>
+        <p:nvSpPr>
+          <p:cNvPr id="12" name="Rounded Rectangle 11"/>
+          <p:cNvSpPr/>
+          <p:nvPr/>
+        </p:nvSpPr>
+        <p:spPr>
+          <a:xfrm>
+            <a:off x="1051560" y="2871215"/>
+            <a:ext cx="1143000" cy="329184"/>
+          </a:xfrm>
+          <a:prstGeom prst="roundRect">
+            <a:avLst/>
+          </a:prstGeom>
+          <a:solidFill>
+            <a:srgbClr val="BE123C"/>
+          </a:solidFill>
+          <a:ln w="9525">
+            <a:solidFill>
+              <a:srgbClr val="BE123C"/>
+            </a:solidFill>
+          </a:ln>
+        </p:spPr>
+        <p:style>
+          <a:lnRef idx="1">
+            <a:schemeClr val="accent1"/>
+          </a:lnRef>
+          <a:fillRef idx="3">
+            <a:schemeClr val="accent1"/>
+          </a:fillRef>
+          <a:effectRef idx="2">
+            <a:schemeClr val="accent1"/>
+          </a:effectRef>
+          <a:fontRef idx="minor">
+            <a:schemeClr val="lt1"/>
+          </a:fontRef>
+        </p:style>
+        <p:txBody>
+          <a:bodyPr rtlCol="0" anchor="ctr"/>
+          <a:lstStyle/>
+          <a:p>
+            <a:pPr algn="ctr"/>
+          </a:p>
+        </p:txBody>
+      </p:sp>
+      <p:sp>
+        <p:nvSpPr>
+          <p:cNvPr id="13" name="TextBox 12"/>
+          <p:cNvSpPr txBox="1"/>
+          <p:nvPr/>
+        </p:nvSpPr>
+        <p:spPr>
+          <a:xfrm>
+            <a:off x="1078992" y="2921508"/>
+            <a:ext cx="1088136" cy="219456"/>
           </a:xfrm>
           <a:prstGeom prst="rect">
             <a:avLst/>
@@ -14032,7 +14673,79 @@
           <a:lstStyle/>
           <a:p>
             <a:pPr algn="ctr">
-              <a:defRPr sz="1500" b="0">
+              <a:defRPr sz="1000" b="1">
+                <a:solidFill>
+                  <a:srgbClr val="FFFFFF"/>
+                </a:solidFill>
+                <a:latin typeface="Malgun Gothic"/>
+              </a:defRPr>
+            </a:pPr>
+            <a:r>
+              <a:t>토론4통합</a:t>
+            </a:r>
+          </a:p>
+        </p:txBody>
+      </p:sp>
+      <p:sp>
+        <p:nvSpPr>
+          <p:cNvPr id="14" name="TextBox 13"/>
+          <p:cNvSpPr txBox="1"/>
+          <p:nvPr/>
+        </p:nvSpPr>
+        <p:spPr>
+          <a:xfrm>
+            <a:off x="2395728" y="2816352"/>
+            <a:ext cx="2560320" cy="237744"/>
+          </a:xfrm>
+          <a:prstGeom prst="rect">
+            <a:avLst/>
+          </a:prstGeom>
+          <a:noFill/>
+        </p:spPr>
+        <p:txBody>
+          <a:bodyPr wrap="square" lIns="73152" rIns="73152" tIns="36576" bIns="36576" anchor="t">
+            <a:spAutoFit/>
+          </a:bodyPr>
+          <a:lstStyle/>
+          <a:p>
+            <a:pPr algn="l">
+              <a:defRPr sz="1300" b="1">
+                <a:solidFill>
+                  <a:srgbClr val="1F2937"/>
+                </a:solidFill>
+                <a:latin typeface="Malgun Gothic"/>
+              </a:defRPr>
+            </a:pPr>
+            <a:r>
+              <a:t>6/14 토론4 통합 운영</a:t>
+            </a:r>
+          </a:p>
+        </p:txBody>
+      </p:sp>
+      <p:sp>
+        <p:nvSpPr>
+          <p:cNvPr id="15" name="TextBox 14"/>
+          <p:cNvSpPr txBox="1"/>
+          <p:nvPr/>
+        </p:nvSpPr>
+        <p:spPr>
+          <a:xfrm>
+            <a:off x="5166360" y="2843784"/>
+            <a:ext cx="5349240" cy="219456"/>
+          </a:xfrm>
+          <a:prstGeom prst="rect">
+            <a:avLst/>
+          </a:prstGeom>
+          <a:noFill/>
+        </p:spPr>
+        <p:txBody>
+          <a:bodyPr wrap="square" lIns="73152" rIns="73152" tIns="36576" bIns="36576" anchor="t">
+            <a:spAutoFit/>
+          </a:bodyPr>
+          <a:lstStyle/>
+          <a:p>
+            <a:pPr algn="l">
+              <a:defRPr sz="1000" b="0">
                 <a:solidFill>
                   <a:srgbClr val="64748B"/>
                 </a:solidFill>
@@ -14040,7 +14753,241 @@
               </a:defRPr>
             </a:pPr>
             <a:r>
-              <a:t>단, 데이터 반영 범위는 정직하게 말한다: A-only는 아니지만, partial/gap 3건은 별도 재확인 대상이다.</a:t>
+              <a:t>상태: needs_review / 전사: transcript_partial / 그래프: not_expected_in_current_graph / 노드: 0</a:t>
+            </a:r>
+          </a:p>
+        </p:txBody>
+      </p:sp>
+      <p:sp>
+        <p:nvSpPr>
+          <p:cNvPr id="16" name="Rounded Rectangle 15"/>
+          <p:cNvSpPr/>
+          <p:nvPr/>
+        </p:nvSpPr>
+        <p:spPr>
+          <a:xfrm>
+            <a:off x="822960" y="3794760"/>
+            <a:ext cx="10424160" cy="841248"/>
+          </a:xfrm>
+          <a:prstGeom prst="roundRect">
+            <a:avLst/>
+          </a:prstGeom>
+          <a:solidFill>
+            <a:srgbClr val="FFFFFF"/>
+          </a:solidFill>
+          <a:ln w="9525">
+            <a:solidFill>
+              <a:srgbClr val="BE123C"/>
+            </a:solidFill>
+          </a:ln>
+        </p:spPr>
+        <p:style>
+          <a:lnRef idx="1">
+            <a:schemeClr val="accent1"/>
+          </a:lnRef>
+          <a:fillRef idx="3">
+            <a:schemeClr val="accent1"/>
+          </a:fillRef>
+          <a:effectRef idx="2">
+            <a:schemeClr val="accent1"/>
+          </a:effectRef>
+          <a:fontRef idx="minor">
+            <a:schemeClr val="lt1"/>
+          </a:fontRef>
+        </p:style>
+        <p:txBody>
+          <a:bodyPr rtlCol="0" anchor="ctr"/>
+          <a:lstStyle/>
+          <a:p>
+            <a:pPr algn="ctr"/>
+          </a:p>
+        </p:txBody>
+      </p:sp>
+      <p:sp>
+        <p:nvSpPr>
+          <p:cNvPr id="17" name="Rounded Rectangle 16"/>
+          <p:cNvSpPr/>
+          <p:nvPr/>
+        </p:nvSpPr>
+        <p:spPr>
+          <a:xfrm>
+            <a:off x="1051560" y="4014216"/>
+            <a:ext cx="1143000" cy="329184"/>
+          </a:xfrm>
+          <a:prstGeom prst="roundRect">
+            <a:avLst/>
+          </a:prstGeom>
+          <a:solidFill>
+            <a:srgbClr val="BE123C"/>
+          </a:solidFill>
+          <a:ln w="9525">
+            <a:solidFill>
+              <a:srgbClr val="BE123C"/>
+            </a:solidFill>
+          </a:ln>
+        </p:spPr>
+        <p:style>
+          <a:lnRef idx="1">
+            <a:schemeClr val="accent1"/>
+          </a:lnRef>
+          <a:fillRef idx="3">
+            <a:schemeClr val="accent1"/>
+          </a:fillRef>
+          <a:effectRef idx="2">
+            <a:schemeClr val="accent1"/>
+          </a:effectRef>
+          <a:fontRef idx="minor">
+            <a:schemeClr val="lt1"/>
+          </a:fontRef>
+        </p:style>
+        <p:txBody>
+          <a:bodyPr rtlCol="0" anchor="ctr"/>
+          <a:lstStyle/>
+          <a:p>
+            <a:pPr algn="ctr"/>
+          </a:p>
+        </p:txBody>
+      </p:sp>
+      <p:sp>
+        <p:nvSpPr>
+          <p:cNvPr id="18" name="TextBox 17"/>
+          <p:cNvSpPr txBox="1"/>
+          <p:nvPr/>
+        </p:nvSpPr>
+        <p:spPr>
+          <a:xfrm>
+            <a:off x="1078992" y="4064508"/>
+            <a:ext cx="1088136" cy="219456"/>
+          </a:xfrm>
+          <a:prstGeom prst="rect">
+            <a:avLst/>
+          </a:prstGeom>
+          <a:noFill/>
+        </p:spPr>
+        <p:txBody>
+          <a:bodyPr wrap="square" lIns="73152" rIns="73152" tIns="36576" bIns="36576" anchor="t">
+            <a:spAutoFit/>
+          </a:bodyPr>
+          <a:lstStyle/>
+          <a:p>
+            <a:pPr algn="ctr">
+              <a:defRPr sz="1000" b="1">
+                <a:solidFill>
+                  <a:srgbClr val="FFFFFF"/>
+                </a:solidFill>
+                <a:latin typeface="Malgun Gothic"/>
+              </a:defRPr>
+            </a:pPr>
+            <a:r>
+              <a:t>음성002</a:t>
+            </a:r>
+          </a:p>
+        </p:txBody>
+      </p:sp>
+      <p:sp>
+        <p:nvSpPr>
+          <p:cNvPr id="19" name="TextBox 18"/>
+          <p:cNvSpPr txBox="1"/>
+          <p:nvPr/>
+        </p:nvSpPr>
+        <p:spPr>
+          <a:xfrm>
+            <a:off x="2395728" y="3959352"/>
+            <a:ext cx="2560320" cy="237744"/>
+          </a:xfrm>
+          <a:prstGeom prst="rect">
+            <a:avLst/>
+          </a:prstGeom>
+          <a:noFill/>
+        </p:spPr>
+        <p:txBody>
+          <a:bodyPr wrap="square" lIns="73152" rIns="73152" tIns="36576" bIns="36576" anchor="t">
+            <a:spAutoFit/>
+          </a:bodyPr>
+          <a:lstStyle/>
+          <a:p>
+            <a:pPr algn="l">
+              <a:defRPr sz="1300" b="1">
+                <a:solidFill>
+                  <a:srgbClr val="1F2937"/>
+                </a:solidFill>
+                <a:latin typeface="Malgun Gothic"/>
+              </a:defRPr>
+            </a:pPr>
+            <a:r>
+              <a:t>음성 002</a:t>
+            </a:r>
+          </a:p>
+        </p:txBody>
+      </p:sp>
+      <p:sp>
+        <p:nvSpPr>
+          <p:cNvPr id="20" name="TextBox 19"/>
+          <p:cNvSpPr txBox="1"/>
+          <p:nvPr/>
+        </p:nvSpPr>
+        <p:spPr>
+          <a:xfrm>
+            <a:off x="5166360" y="3986784"/>
+            <a:ext cx="5349240" cy="219456"/>
+          </a:xfrm>
+          <a:prstGeom prst="rect">
+            <a:avLst/>
+          </a:prstGeom>
+          <a:noFill/>
+        </p:spPr>
+        <p:txBody>
+          <a:bodyPr wrap="square" lIns="73152" rIns="73152" tIns="36576" bIns="36576" anchor="t">
+            <a:spAutoFit/>
+          </a:bodyPr>
+          <a:lstStyle/>
+          <a:p>
+            <a:pPr algn="l">
+              <a:defRPr sz="1000" b="0">
+                <a:solidFill>
+                  <a:srgbClr val="64748B"/>
+                </a:solidFill>
+                <a:latin typeface="Malgun Gothic"/>
+              </a:defRPr>
+            </a:pPr>
+            <a:r>
+              <a:t>상태: ui_or_graph_gap / 전사: transcript_ready / 그래프: not_expected_in_current_graph / 노드: 0</a:t>
+            </a:r>
+          </a:p>
+        </p:txBody>
+      </p:sp>
+      <p:sp>
+        <p:nvSpPr>
+          <p:cNvPr id="21" name="TextBox 20"/>
+          <p:cNvSpPr txBox="1"/>
+          <p:nvPr/>
+        </p:nvSpPr>
+        <p:spPr>
+          <a:xfrm>
+            <a:off x="960120" y="5303520"/>
+            <a:ext cx="10058400" cy="384048"/>
+          </a:xfrm>
+          <a:prstGeom prst="rect">
+            <a:avLst/>
+          </a:prstGeom>
+          <a:noFill/>
+        </p:spPr>
+        <p:txBody>
+          <a:bodyPr wrap="square" lIns="73152" rIns="73152" tIns="36576" bIns="36576" anchor="t">
+            <a:spAutoFit/>
+          </a:bodyPr>
+          <a:lstStyle/>
+          <a:p>
+            <a:pPr algn="ctr">
+              <a:defRPr sz="1700" b="1">
+                <a:solidFill>
+                  <a:srgbClr val="BE123C"/>
+                </a:solidFill>
+                <a:latin typeface="Malgun Gothic"/>
+              </a:defRPr>
+            </a:pPr>
+            <a:r>
+              <a:t>이 3건이 남아 있기 때문에 `모든 입력이 완전 반영`이라는 표현은 아직 금물이다.</a:t>
             </a:r>
           </a:p>
         </p:txBody>

</xml_diff>